<commit_message>
miguelangel inspiraod, yo confio
</commit_message>
<xml_diff>
--- a/LabBook_10.pptx
+++ b/LabBook_10.pptx
@@ -268,7 +268,7 @@
           <a:p>
             <a:fld id="{8438F8DC-35B0-48E6-A86E-42F1F08DD00F}" type="datetimeFigureOut">
               <a:rPr lang="es-ES" smtClean="0"/>
-              <a:t>06/03/2026</a:t>
+              <a:t>07/03/2026</a:t>
             </a:fld>
             <a:endParaRPr lang="es-ES"/>
           </a:p>
@@ -445,7 +445,7 @@
           <a:p>
             <a:fld id="{FACBDC12-F39B-4B97-8F4D-6734F9D366FF}" type="datetimeFigureOut">
               <a:rPr lang="es-ES" smtClean="0"/>
-              <a:t>06/03/2026</a:t>
+              <a:t>07/03/2026</a:t>
             </a:fld>
             <a:endParaRPr lang="es-ES"/>
           </a:p>
@@ -3551,6 +3551,66 @@
           </a:p>
         </p:txBody>
       </p:sp>
+      <p:pic>
+        <p:nvPicPr>
+          <p:cNvPr id="9" name="Imagen 8">
+            <a:extLst>
+              <a:ext uri="{FF2B5EF4-FFF2-40B4-BE49-F238E27FC236}">
+                <a16:creationId xmlns:a16="http://schemas.microsoft.com/office/drawing/2014/main" id="{F8D6361A-60D6-D762-4EEC-7D641561139F}"/>
+              </a:ext>
+            </a:extLst>
+          </p:cNvPr>
+          <p:cNvPicPr>
+            <a:picLocks noChangeAspect="1"/>
+          </p:cNvPicPr>
+          <p:nvPr/>
+        </p:nvPicPr>
+        <p:blipFill>
+          <a:blip r:embed="rId5"/>
+          <a:stretch>
+            <a:fillRect/>
+          </a:stretch>
+        </p:blipFill>
+        <p:spPr>
+          <a:xfrm>
+            <a:off x="1524000" y="1739453"/>
+            <a:ext cx="3429000" cy="2708672"/>
+          </a:xfrm>
+          <a:prstGeom prst="rect">
+            <a:avLst/>
+          </a:prstGeom>
+        </p:spPr>
+      </p:pic>
+      <p:pic>
+        <p:nvPicPr>
+          <p:cNvPr id="11" name="Imagen 10">
+            <a:extLst>
+              <a:ext uri="{FF2B5EF4-FFF2-40B4-BE49-F238E27FC236}">
+                <a16:creationId xmlns:a16="http://schemas.microsoft.com/office/drawing/2014/main" id="{E06F18D7-4C12-4E46-4877-EE4E7B6B5983}"/>
+              </a:ext>
+            </a:extLst>
+          </p:cNvPr>
+          <p:cNvPicPr>
+            <a:picLocks noChangeAspect="1"/>
+          </p:cNvPicPr>
+          <p:nvPr/>
+        </p:nvPicPr>
+        <p:blipFill>
+          <a:blip r:embed="rId6"/>
+          <a:stretch>
+            <a:fillRect/>
+          </a:stretch>
+        </p:blipFill>
+        <p:spPr>
+          <a:xfrm>
+            <a:off x="6850725" y="1606918"/>
+            <a:ext cx="3817274" cy="2928937"/>
+          </a:xfrm>
+          <a:prstGeom prst="rect">
+            <a:avLst/>
+          </a:prstGeom>
+        </p:spPr>
+      </p:pic>
     </p:spTree>
     <p:extLst>
       <p:ext uri="{BB962C8B-B14F-4D97-AF65-F5344CB8AC3E}">
@@ -8156,10 +8216,9 @@
               </a:spcBef>
             </a:pPr>
             <a:r>
-              <a:rPr lang="es-ES" spc="-5"/>
+              <a:rPr lang="es-ES" spc="-5" dirty="0"/>
               <a:t>LAB 1.0 WAVEGUIDES</a:t>
             </a:r>
-            <a:endParaRPr lang="es-ES" spc="-5" dirty="0"/>
           </a:p>
         </p:txBody>
       </p:sp>

</xml_diff>

<commit_message>
hecho apartado extra.1 y planteado en power
</commit_message>
<xml_diff>
--- a/LabBook_10.pptx
+++ b/LabBook_10.pptx
@@ -5,10 +5,10 @@
     <p:sldMasterId id="2147483648" r:id="rId1"/>
   </p:sldMasterIdLst>
   <p:notesMasterIdLst>
-    <p:notesMasterId r:id="rId13"/>
+    <p:notesMasterId r:id="rId17"/>
   </p:notesMasterIdLst>
   <p:handoutMasterIdLst>
-    <p:handoutMasterId r:id="rId14"/>
+    <p:handoutMasterId r:id="rId18"/>
   </p:handoutMasterIdLst>
   <p:sldIdLst>
     <p:sldId id="256" r:id="rId2"/>
@@ -21,7 +21,11 @@
     <p:sldId id="292" r:id="rId9"/>
     <p:sldId id="297" r:id="rId10"/>
     <p:sldId id="293" r:id="rId11"/>
-    <p:sldId id="288" r:id="rId12"/>
+    <p:sldId id="301" r:id="rId12"/>
+    <p:sldId id="302" r:id="rId13"/>
+    <p:sldId id="303" r:id="rId14"/>
+    <p:sldId id="304" r:id="rId15"/>
+    <p:sldId id="288" r:id="rId16"/>
   </p:sldIdLst>
   <p:sldSz cx="12192000" cy="6858000"/>
   <p:notesSz cx="12192000" cy="6858000"/>
@@ -796,6 +800,330 @@
 </p:notes>
 </file>
 
+<file path=ppt/notesSlides/notesSlide10.xml><?xml version="1.0" encoding="utf-8"?>
+<p:notes xmlns:a="http://schemas.openxmlformats.org/drawingml/2006/main" xmlns:r="http://schemas.openxmlformats.org/officeDocument/2006/relationships" xmlns:p="http://schemas.openxmlformats.org/presentationml/2006/main">
+  <p:cSld>
+    <p:spTree>
+      <p:nvGrpSpPr>
+        <p:cNvPr id="1" name="">
+          <a:extLst>
+            <a:ext uri="{FF2B5EF4-FFF2-40B4-BE49-F238E27FC236}">
+              <a16:creationId xmlns:a16="http://schemas.microsoft.com/office/drawing/2014/main" id="{34C2C07F-E18C-9CA1-2FE6-7E5EB7B80A6B}"/>
+            </a:ext>
+          </a:extLst>
+        </p:cNvPr>
+        <p:cNvGrpSpPr/>
+        <p:nvPr/>
+      </p:nvGrpSpPr>
+      <p:grpSpPr>
+        <a:xfrm>
+          <a:off x="0" y="0"/>
+          <a:ext cx="0" cy="0"/>
+          <a:chOff x="0" y="0"/>
+          <a:chExt cx="0" cy="0"/>
+        </a:xfrm>
+      </p:grpSpPr>
+      <p:sp>
+        <p:nvSpPr>
+          <p:cNvPr id="2" name="Marcador de imagen de diapositiva 1">
+            <a:extLst>
+              <a:ext uri="{FF2B5EF4-FFF2-40B4-BE49-F238E27FC236}">
+                <a16:creationId xmlns:a16="http://schemas.microsoft.com/office/drawing/2014/main" id="{C7BA0930-6213-7538-A132-6A6802721882}"/>
+              </a:ext>
+            </a:extLst>
+          </p:cNvPr>
+          <p:cNvSpPr>
+            <a:spLocks noGrp="1" noRot="1" noChangeAspect="1"/>
+          </p:cNvSpPr>
+          <p:nvPr>
+            <p:ph type="sldImg"/>
+          </p:nvPr>
+        </p:nvSpPr>
+        <p:spPr/>
+      </p:sp>
+      <p:sp>
+        <p:nvSpPr>
+          <p:cNvPr id="3" name="Marcador de notas 2">
+            <a:extLst>
+              <a:ext uri="{FF2B5EF4-FFF2-40B4-BE49-F238E27FC236}">
+                <a16:creationId xmlns:a16="http://schemas.microsoft.com/office/drawing/2014/main" id="{638A00DA-25FA-4704-3696-91386D808040}"/>
+              </a:ext>
+            </a:extLst>
+          </p:cNvPr>
+          <p:cNvSpPr>
+            <a:spLocks noGrp="1"/>
+          </p:cNvSpPr>
+          <p:nvPr>
+            <p:ph type="body" idx="1"/>
+          </p:nvPr>
+        </p:nvSpPr>
+        <p:spPr/>
+        <p:txBody>
+          <a:bodyPr/>
+          <a:lstStyle/>
+          <a:p>
+            <a:endParaRPr lang="es-ES" dirty="0"/>
+          </a:p>
+        </p:txBody>
+      </p:sp>
+      <p:sp>
+        <p:nvSpPr>
+          <p:cNvPr id="4" name="Marcador de número de diapositiva 3">
+            <a:extLst>
+              <a:ext uri="{FF2B5EF4-FFF2-40B4-BE49-F238E27FC236}">
+                <a16:creationId xmlns:a16="http://schemas.microsoft.com/office/drawing/2014/main" id="{78998A66-5D98-A9ED-6975-5A39135A37B3}"/>
+              </a:ext>
+            </a:extLst>
+          </p:cNvPr>
+          <p:cNvSpPr>
+            <a:spLocks noGrp="1"/>
+          </p:cNvSpPr>
+          <p:nvPr>
+            <p:ph type="sldNum" sz="quarter" idx="5"/>
+          </p:nvPr>
+        </p:nvSpPr>
+        <p:spPr/>
+        <p:txBody>
+          <a:bodyPr/>
+          <a:lstStyle/>
+          <a:p>
+            <a:fld id="{676223B9-C868-4436-87D9-1A3152E1157A}" type="slidenum">
+              <a:rPr lang="es-ES" smtClean="0"/>
+              <a:t>12</a:t>
+            </a:fld>
+            <a:endParaRPr lang="es-ES"/>
+          </a:p>
+        </p:txBody>
+      </p:sp>
+    </p:spTree>
+    <p:extLst>
+      <p:ext uri="{BB962C8B-B14F-4D97-AF65-F5344CB8AC3E}">
+        <p14:creationId xmlns:p14="http://schemas.microsoft.com/office/powerpoint/2010/main" val="737430653"/>
+      </p:ext>
+    </p:extLst>
+  </p:cSld>
+  <p:clrMapOvr>
+    <a:masterClrMapping/>
+  </p:clrMapOvr>
+</p:notes>
+</file>
+
+<file path=ppt/notesSlides/notesSlide11.xml><?xml version="1.0" encoding="utf-8"?>
+<p:notes xmlns:a="http://schemas.openxmlformats.org/drawingml/2006/main" xmlns:r="http://schemas.openxmlformats.org/officeDocument/2006/relationships" xmlns:p="http://schemas.openxmlformats.org/presentationml/2006/main">
+  <p:cSld>
+    <p:spTree>
+      <p:nvGrpSpPr>
+        <p:cNvPr id="1" name="">
+          <a:extLst>
+            <a:ext uri="{FF2B5EF4-FFF2-40B4-BE49-F238E27FC236}">
+              <a16:creationId xmlns:a16="http://schemas.microsoft.com/office/drawing/2014/main" id="{4CFF2CC8-05DB-4691-975B-5CB4F6F72229}"/>
+            </a:ext>
+          </a:extLst>
+        </p:cNvPr>
+        <p:cNvGrpSpPr/>
+        <p:nvPr/>
+      </p:nvGrpSpPr>
+      <p:grpSpPr>
+        <a:xfrm>
+          <a:off x="0" y="0"/>
+          <a:ext cx="0" cy="0"/>
+          <a:chOff x="0" y="0"/>
+          <a:chExt cx="0" cy="0"/>
+        </a:xfrm>
+      </p:grpSpPr>
+      <p:sp>
+        <p:nvSpPr>
+          <p:cNvPr id="2" name="Marcador de imagen de diapositiva 1">
+            <a:extLst>
+              <a:ext uri="{FF2B5EF4-FFF2-40B4-BE49-F238E27FC236}">
+                <a16:creationId xmlns:a16="http://schemas.microsoft.com/office/drawing/2014/main" id="{4E0BA263-33B5-7053-6336-32E955917816}"/>
+              </a:ext>
+            </a:extLst>
+          </p:cNvPr>
+          <p:cNvSpPr>
+            <a:spLocks noGrp="1" noRot="1" noChangeAspect="1"/>
+          </p:cNvSpPr>
+          <p:nvPr>
+            <p:ph type="sldImg"/>
+          </p:nvPr>
+        </p:nvSpPr>
+        <p:spPr/>
+      </p:sp>
+      <p:sp>
+        <p:nvSpPr>
+          <p:cNvPr id="3" name="Marcador de notas 2">
+            <a:extLst>
+              <a:ext uri="{FF2B5EF4-FFF2-40B4-BE49-F238E27FC236}">
+                <a16:creationId xmlns:a16="http://schemas.microsoft.com/office/drawing/2014/main" id="{9C1ACDD5-0C09-CF66-497D-1725738EE0DF}"/>
+              </a:ext>
+            </a:extLst>
+          </p:cNvPr>
+          <p:cNvSpPr>
+            <a:spLocks noGrp="1"/>
+          </p:cNvSpPr>
+          <p:nvPr>
+            <p:ph type="body" idx="1"/>
+          </p:nvPr>
+        </p:nvSpPr>
+        <p:spPr/>
+        <p:txBody>
+          <a:bodyPr/>
+          <a:lstStyle/>
+          <a:p>
+            <a:endParaRPr lang="es-ES" dirty="0"/>
+          </a:p>
+        </p:txBody>
+      </p:sp>
+      <p:sp>
+        <p:nvSpPr>
+          <p:cNvPr id="4" name="Marcador de número de diapositiva 3">
+            <a:extLst>
+              <a:ext uri="{FF2B5EF4-FFF2-40B4-BE49-F238E27FC236}">
+                <a16:creationId xmlns:a16="http://schemas.microsoft.com/office/drawing/2014/main" id="{89F05E02-6563-E17B-67B8-CBA0BE8A22D0}"/>
+              </a:ext>
+            </a:extLst>
+          </p:cNvPr>
+          <p:cNvSpPr>
+            <a:spLocks noGrp="1"/>
+          </p:cNvSpPr>
+          <p:nvPr>
+            <p:ph type="sldNum" sz="quarter" idx="5"/>
+          </p:nvPr>
+        </p:nvSpPr>
+        <p:spPr/>
+        <p:txBody>
+          <a:bodyPr/>
+          <a:lstStyle/>
+          <a:p>
+            <a:fld id="{676223B9-C868-4436-87D9-1A3152E1157A}" type="slidenum">
+              <a:rPr lang="es-ES" smtClean="0"/>
+              <a:t>13</a:t>
+            </a:fld>
+            <a:endParaRPr lang="es-ES"/>
+          </a:p>
+        </p:txBody>
+      </p:sp>
+    </p:spTree>
+    <p:extLst>
+      <p:ext uri="{BB962C8B-B14F-4D97-AF65-F5344CB8AC3E}">
+        <p14:creationId xmlns:p14="http://schemas.microsoft.com/office/powerpoint/2010/main" val="3072001755"/>
+      </p:ext>
+    </p:extLst>
+  </p:cSld>
+  <p:clrMapOvr>
+    <a:masterClrMapping/>
+  </p:clrMapOvr>
+</p:notes>
+</file>
+
+<file path=ppt/notesSlides/notesSlide12.xml><?xml version="1.0" encoding="utf-8"?>
+<p:notes xmlns:a="http://schemas.openxmlformats.org/drawingml/2006/main" xmlns:r="http://schemas.openxmlformats.org/officeDocument/2006/relationships" xmlns:p="http://schemas.openxmlformats.org/presentationml/2006/main">
+  <p:cSld>
+    <p:spTree>
+      <p:nvGrpSpPr>
+        <p:cNvPr id="1" name="">
+          <a:extLst>
+            <a:ext uri="{FF2B5EF4-FFF2-40B4-BE49-F238E27FC236}">
+              <a16:creationId xmlns:a16="http://schemas.microsoft.com/office/drawing/2014/main" id="{868F883C-2214-83DE-A46F-0B4499EEAD7F}"/>
+            </a:ext>
+          </a:extLst>
+        </p:cNvPr>
+        <p:cNvGrpSpPr/>
+        <p:nvPr/>
+      </p:nvGrpSpPr>
+      <p:grpSpPr>
+        <a:xfrm>
+          <a:off x="0" y="0"/>
+          <a:ext cx="0" cy="0"/>
+          <a:chOff x="0" y="0"/>
+          <a:chExt cx="0" cy="0"/>
+        </a:xfrm>
+      </p:grpSpPr>
+      <p:sp>
+        <p:nvSpPr>
+          <p:cNvPr id="2" name="Marcador de imagen de diapositiva 1">
+            <a:extLst>
+              <a:ext uri="{FF2B5EF4-FFF2-40B4-BE49-F238E27FC236}">
+                <a16:creationId xmlns:a16="http://schemas.microsoft.com/office/drawing/2014/main" id="{3644840D-1C40-39C0-A29B-92A9DEDB14B5}"/>
+              </a:ext>
+            </a:extLst>
+          </p:cNvPr>
+          <p:cNvSpPr>
+            <a:spLocks noGrp="1" noRot="1" noChangeAspect="1"/>
+          </p:cNvSpPr>
+          <p:nvPr>
+            <p:ph type="sldImg"/>
+          </p:nvPr>
+        </p:nvSpPr>
+        <p:spPr/>
+      </p:sp>
+      <p:sp>
+        <p:nvSpPr>
+          <p:cNvPr id="3" name="Marcador de notas 2">
+            <a:extLst>
+              <a:ext uri="{FF2B5EF4-FFF2-40B4-BE49-F238E27FC236}">
+                <a16:creationId xmlns:a16="http://schemas.microsoft.com/office/drawing/2014/main" id="{1E00F841-88B5-28D2-B8AD-7572489A8563}"/>
+              </a:ext>
+            </a:extLst>
+          </p:cNvPr>
+          <p:cNvSpPr>
+            <a:spLocks noGrp="1"/>
+          </p:cNvSpPr>
+          <p:nvPr>
+            <p:ph type="body" idx="1"/>
+          </p:nvPr>
+        </p:nvSpPr>
+        <p:spPr/>
+        <p:txBody>
+          <a:bodyPr/>
+          <a:lstStyle/>
+          <a:p>
+            <a:endParaRPr lang="es-ES" dirty="0"/>
+          </a:p>
+        </p:txBody>
+      </p:sp>
+      <p:sp>
+        <p:nvSpPr>
+          <p:cNvPr id="4" name="Marcador de número de diapositiva 3">
+            <a:extLst>
+              <a:ext uri="{FF2B5EF4-FFF2-40B4-BE49-F238E27FC236}">
+                <a16:creationId xmlns:a16="http://schemas.microsoft.com/office/drawing/2014/main" id="{CD20CB20-0871-B81E-C209-7CB477169152}"/>
+              </a:ext>
+            </a:extLst>
+          </p:cNvPr>
+          <p:cNvSpPr>
+            <a:spLocks noGrp="1"/>
+          </p:cNvSpPr>
+          <p:nvPr>
+            <p:ph type="sldNum" sz="quarter" idx="5"/>
+          </p:nvPr>
+        </p:nvSpPr>
+        <p:spPr/>
+        <p:txBody>
+          <a:bodyPr/>
+          <a:lstStyle/>
+          <a:p>
+            <a:fld id="{676223B9-C868-4436-87D9-1A3152E1157A}" type="slidenum">
+              <a:rPr lang="es-ES" smtClean="0"/>
+              <a:t>14</a:t>
+            </a:fld>
+            <a:endParaRPr lang="es-ES"/>
+          </a:p>
+        </p:txBody>
+      </p:sp>
+    </p:spTree>
+    <p:extLst>
+      <p:ext uri="{BB962C8B-B14F-4D97-AF65-F5344CB8AC3E}">
+        <p14:creationId xmlns:p14="http://schemas.microsoft.com/office/powerpoint/2010/main" val="2941625907"/>
+      </p:ext>
+    </p:extLst>
+  </p:cSld>
+  <p:clrMapOvr>
+    <a:masterClrMapping/>
+  </p:clrMapOvr>
+</p:notes>
+</file>
+
 <file path=ppt/notesSlides/notesSlide2.xml><?xml version="1.0" encoding="utf-8"?>
 <p:notes xmlns:a="http://schemas.openxmlformats.org/drawingml/2006/main" xmlns:r="http://schemas.openxmlformats.org/officeDocument/2006/relationships" xmlns:p="http://schemas.openxmlformats.org/presentationml/2006/main">
   <p:cSld>
@@ -1543,6 +1871,114 @@
     <p:extLst>
       <p:ext uri="{BB962C8B-B14F-4D97-AF65-F5344CB8AC3E}">
         <p14:creationId xmlns:p14="http://schemas.microsoft.com/office/powerpoint/2010/main" val="2917382716"/>
+      </p:ext>
+    </p:extLst>
+  </p:cSld>
+  <p:clrMapOvr>
+    <a:masterClrMapping/>
+  </p:clrMapOvr>
+</p:notes>
+</file>
+
+<file path=ppt/notesSlides/notesSlide9.xml><?xml version="1.0" encoding="utf-8"?>
+<p:notes xmlns:a="http://schemas.openxmlformats.org/drawingml/2006/main" xmlns:r="http://schemas.openxmlformats.org/officeDocument/2006/relationships" xmlns:p="http://schemas.openxmlformats.org/presentationml/2006/main">
+  <p:cSld>
+    <p:spTree>
+      <p:nvGrpSpPr>
+        <p:cNvPr id="1" name="">
+          <a:extLst>
+            <a:ext uri="{FF2B5EF4-FFF2-40B4-BE49-F238E27FC236}">
+              <a16:creationId xmlns:a16="http://schemas.microsoft.com/office/drawing/2014/main" id="{23F372A6-6C95-E4D4-BF5C-B643A29942BD}"/>
+            </a:ext>
+          </a:extLst>
+        </p:cNvPr>
+        <p:cNvGrpSpPr/>
+        <p:nvPr/>
+      </p:nvGrpSpPr>
+      <p:grpSpPr>
+        <a:xfrm>
+          <a:off x="0" y="0"/>
+          <a:ext cx="0" cy="0"/>
+          <a:chOff x="0" y="0"/>
+          <a:chExt cx="0" cy="0"/>
+        </a:xfrm>
+      </p:grpSpPr>
+      <p:sp>
+        <p:nvSpPr>
+          <p:cNvPr id="2" name="Marcador de imagen de diapositiva 1">
+            <a:extLst>
+              <a:ext uri="{FF2B5EF4-FFF2-40B4-BE49-F238E27FC236}">
+                <a16:creationId xmlns:a16="http://schemas.microsoft.com/office/drawing/2014/main" id="{6CA5B3AE-FFEA-66C4-12E9-861082361B65}"/>
+              </a:ext>
+            </a:extLst>
+          </p:cNvPr>
+          <p:cNvSpPr>
+            <a:spLocks noGrp="1" noRot="1" noChangeAspect="1"/>
+          </p:cNvSpPr>
+          <p:nvPr>
+            <p:ph type="sldImg"/>
+          </p:nvPr>
+        </p:nvSpPr>
+        <p:spPr/>
+      </p:sp>
+      <p:sp>
+        <p:nvSpPr>
+          <p:cNvPr id="3" name="Marcador de notas 2">
+            <a:extLst>
+              <a:ext uri="{FF2B5EF4-FFF2-40B4-BE49-F238E27FC236}">
+                <a16:creationId xmlns:a16="http://schemas.microsoft.com/office/drawing/2014/main" id="{171FF9E9-532D-BE68-1E4F-4E86497D4B08}"/>
+              </a:ext>
+            </a:extLst>
+          </p:cNvPr>
+          <p:cNvSpPr>
+            <a:spLocks noGrp="1"/>
+          </p:cNvSpPr>
+          <p:nvPr>
+            <p:ph type="body" idx="1"/>
+          </p:nvPr>
+        </p:nvSpPr>
+        <p:spPr/>
+        <p:txBody>
+          <a:bodyPr/>
+          <a:lstStyle/>
+          <a:p>
+            <a:endParaRPr lang="es-ES" dirty="0"/>
+          </a:p>
+        </p:txBody>
+      </p:sp>
+      <p:sp>
+        <p:nvSpPr>
+          <p:cNvPr id="4" name="Marcador de número de diapositiva 3">
+            <a:extLst>
+              <a:ext uri="{FF2B5EF4-FFF2-40B4-BE49-F238E27FC236}">
+                <a16:creationId xmlns:a16="http://schemas.microsoft.com/office/drawing/2014/main" id="{D024E5AF-CFAF-AABF-8D97-2F2BE50E7C80}"/>
+              </a:ext>
+            </a:extLst>
+          </p:cNvPr>
+          <p:cNvSpPr>
+            <a:spLocks noGrp="1"/>
+          </p:cNvSpPr>
+          <p:nvPr>
+            <p:ph type="sldNum" sz="quarter" idx="5"/>
+          </p:nvPr>
+        </p:nvSpPr>
+        <p:spPr/>
+        <p:txBody>
+          <a:bodyPr/>
+          <a:lstStyle/>
+          <a:p>
+            <a:fld id="{676223B9-C868-4436-87D9-1A3152E1157A}" type="slidenum">
+              <a:rPr lang="es-ES" smtClean="0"/>
+              <a:t>11</a:t>
+            </a:fld>
+            <a:endParaRPr lang="es-ES"/>
+          </a:p>
+        </p:txBody>
+      </p:sp>
+    </p:spTree>
+    <p:extLst>
+      <p:ext uri="{BB962C8B-B14F-4D97-AF65-F5344CB8AC3E}">
+        <p14:creationId xmlns:p14="http://schemas.microsoft.com/office/powerpoint/2010/main" val="2006642282"/>
       </p:ext>
     </p:extLst>
   </p:cSld>
@@ -3629,6 +4065,1491 @@
   <p:cSld>
     <p:spTree>
       <p:nvGrpSpPr>
+        <p:cNvPr id="1" name="">
+          <a:extLst>
+            <a:ext uri="{FF2B5EF4-FFF2-40B4-BE49-F238E27FC236}">
+              <a16:creationId xmlns:a16="http://schemas.microsoft.com/office/drawing/2014/main" id="{78D6BBC3-5145-4705-5F65-216325E77B3E}"/>
+            </a:ext>
+          </a:extLst>
+        </p:cNvPr>
+        <p:cNvGrpSpPr/>
+        <p:nvPr/>
+      </p:nvGrpSpPr>
+      <p:grpSpPr>
+        <a:xfrm>
+          <a:off x="0" y="0"/>
+          <a:ext cx="0" cy="0"/>
+          <a:chOff x="0" y="0"/>
+          <a:chExt cx="0" cy="0"/>
+        </a:xfrm>
+      </p:grpSpPr>
+      <p:sp>
+        <p:nvSpPr>
+          <p:cNvPr id="16" name="object 16">
+            <a:extLst>
+              <a:ext uri="{FF2B5EF4-FFF2-40B4-BE49-F238E27FC236}">
+                <a16:creationId xmlns:a16="http://schemas.microsoft.com/office/drawing/2014/main" id="{BC15E1E5-7A56-2995-4D67-273F419F1269}"/>
+              </a:ext>
+            </a:extLst>
+          </p:cNvPr>
+          <p:cNvSpPr txBox="1">
+            <a:spLocks noGrp="1"/>
+          </p:cNvSpPr>
+          <p:nvPr>
+            <p:ph type="title"/>
+          </p:nvPr>
+        </p:nvSpPr>
+        <p:spPr>
+          <a:xfrm>
+            <a:off x="685800" y="408883"/>
+            <a:ext cx="10994410" cy="2398092"/>
+          </a:xfrm>
+          <a:prstGeom prst="rect">
+            <a:avLst/>
+          </a:prstGeom>
+        </p:spPr>
+        <p:txBody>
+          <a:bodyPr vert="horz" wrap="square" lIns="0" tIns="12700" rIns="0" bIns="0" rtlCol="0">
+            <a:spAutoFit/>
+          </a:bodyPr>
+          <a:lstStyle/>
+          <a:p>
+            <a:pPr marL="12700">
+              <a:spcBef>
+                <a:spcPts val="100"/>
+              </a:spcBef>
+            </a:pPr>
+            <a:r>
+              <a:rPr lang="en-US" sz="2500" dirty="0"/>
+              <a:t># EXTRA.1 - Wavelength behavior</a:t>
+            </a:r>
+            <a:br>
+              <a:rPr lang="en-US" sz="2500" dirty="0"/>
+            </a:br>
+            <a:r>
+              <a:rPr lang="en-US" b="0" dirty="0"/>
+              <a:t>Now, Simulate the Silicon-On-Insulator technology changing the core material to Silicon (Si). In this case, the dimensions will be 220 nm </a:t>
+            </a:r>
+            <a:r>
+              <a:rPr lang="en-US" b="0" dirty="0" err="1"/>
+              <a:t>heigth</a:t>
+            </a:r>
+            <a:r>
+              <a:rPr lang="en-US" b="0" dirty="0"/>
+              <a:t> and 500 nm width. </a:t>
+            </a:r>
+            <a:br>
+              <a:rPr lang="en-US" b="0" dirty="0"/>
+            </a:br>
+            <a:r>
+              <a:rPr lang="en-US" dirty="0"/>
+              <a:t>1. </a:t>
+            </a:r>
+            <a:r>
+              <a:rPr lang="en-US" b="0" dirty="0"/>
+              <a:t>Repeat the LO.2. wavelength behavior simulations, considering the updated materials and dimensions. </a:t>
+            </a:r>
+            <a:br>
+              <a:rPr lang="en-US" b="0" dirty="0"/>
+            </a:br>
+            <a:br>
+              <a:rPr lang="en-US" b="0" dirty="0"/>
+            </a:br>
+            <a:br>
+              <a:rPr lang="en-US" sz="2500" dirty="0"/>
+            </a:br>
+            <a:endParaRPr lang="en-US" sz="2500" b="0" dirty="0">
+              <a:latin typeface="+mj-lt"/>
+              <a:cs typeface="Lucida Sans"/>
+            </a:endParaRPr>
+          </a:p>
+        </p:txBody>
+      </p:sp>
+      <p:pic>
+        <p:nvPicPr>
+          <p:cNvPr id="83" name="Gráfico 82">
+            <a:extLst>
+              <a:ext uri="{FF2B5EF4-FFF2-40B4-BE49-F238E27FC236}">
+                <a16:creationId xmlns:a16="http://schemas.microsoft.com/office/drawing/2014/main" id="{3402F5B0-BE89-6EC8-DE18-8C9902A6259A}"/>
+              </a:ext>
+            </a:extLst>
+          </p:cNvPr>
+          <p:cNvPicPr>
+            <a:picLocks noChangeAspect="1"/>
+          </p:cNvPicPr>
+          <p:nvPr/>
+        </p:nvPicPr>
+        <p:blipFill>
+          <a:blip r:embed="rId3">
+            <a:extLst>
+              <a:ext uri="{96DAC541-7B7A-43D3-8B79-37D633B846F1}">
+                <asvg:svgBlip xmlns:asvg="http://schemas.microsoft.com/office/drawing/2016/SVG/main" r:embed="rId4"/>
+              </a:ext>
+            </a:extLst>
+          </a:blip>
+          <a:stretch>
+            <a:fillRect/>
+          </a:stretch>
+        </p:blipFill>
+        <p:spPr>
+          <a:xfrm>
+            <a:off x="5045006" y="6356057"/>
+            <a:ext cx="6409575" cy="363174"/>
+          </a:xfrm>
+          <a:prstGeom prst="rect">
+            <a:avLst/>
+          </a:prstGeom>
+        </p:spPr>
+      </p:pic>
+      <p:sp>
+        <p:nvSpPr>
+          <p:cNvPr id="84" name="Marcador de número de diapositiva 83">
+            <a:extLst>
+              <a:ext uri="{FF2B5EF4-FFF2-40B4-BE49-F238E27FC236}">
+                <a16:creationId xmlns:a16="http://schemas.microsoft.com/office/drawing/2014/main" id="{ABED5594-721A-740B-E9D0-284907D21043}"/>
+              </a:ext>
+            </a:extLst>
+          </p:cNvPr>
+          <p:cNvSpPr>
+            <a:spLocks noGrp="1"/>
+          </p:cNvSpPr>
+          <p:nvPr>
+            <p:ph type="sldNum" sz="quarter" idx="7"/>
+          </p:nvPr>
+        </p:nvSpPr>
+        <p:spPr/>
+        <p:txBody>
+          <a:bodyPr/>
+          <a:lstStyle/>
+          <a:p>
+            <a:fld id="{B6F15528-21DE-4FAA-801E-634DDDAF4B2B}" type="slidenum">
+              <a:rPr lang="es-ES" smtClean="0"/>
+              <a:t>11</a:t>
+            </a:fld>
+            <a:endParaRPr lang="es-ES"/>
+          </a:p>
+        </p:txBody>
+      </p:sp>
+      <p:sp>
+        <p:nvSpPr>
+          <p:cNvPr id="3" name="Marcador de pie de página 2">
+            <a:extLst>
+              <a:ext uri="{FF2B5EF4-FFF2-40B4-BE49-F238E27FC236}">
+                <a16:creationId xmlns:a16="http://schemas.microsoft.com/office/drawing/2014/main" id="{E2C3C16A-8F1C-075F-485A-4A291213F56E}"/>
+              </a:ext>
+            </a:extLst>
+          </p:cNvPr>
+          <p:cNvSpPr>
+            <a:spLocks noGrp="1"/>
+          </p:cNvSpPr>
+          <p:nvPr>
+            <p:ph type="ftr" sz="quarter" idx="5"/>
+          </p:nvPr>
+        </p:nvSpPr>
+        <p:spPr/>
+        <p:txBody>
+          <a:bodyPr/>
+          <a:lstStyle/>
+          <a:p>
+            <a:pPr marL="12700">
+              <a:spcBef>
+                <a:spcPts val="15"/>
+              </a:spcBef>
+            </a:pPr>
+            <a:r>
+              <a:rPr lang="es-ES" spc="-5"/>
+              <a:t>LAB 1.0 WAVEGUIDES</a:t>
+            </a:r>
+            <a:endParaRPr lang="es-ES" spc="-5" dirty="0"/>
+          </a:p>
+        </p:txBody>
+      </p:sp>
+      <p:sp>
+        <p:nvSpPr>
+          <p:cNvPr id="2" name="CuadroTexto 1">
+            <a:extLst>
+              <a:ext uri="{FF2B5EF4-FFF2-40B4-BE49-F238E27FC236}">
+                <a16:creationId xmlns:a16="http://schemas.microsoft.com/office/drawing/2014/main" id="{4F885DF2-D695-6C6F-F4F1-913A39EAE30C}"/>
+              </a:ext>
+            </a:extLst>
+          </p:cNvPr>
+          <p:cNvSpPr txBox="1"/>
+          <p:nvPr/>
+        </p:nvSpPr>
+        <p:spPr>
+          <a:xfrm>
+            <a:off x="609441" y="4860334"/>
+            <a:ext cx="11199971" cy="646331"/>
+          </a:xfrm>
+          <a:prstGeom prst="rect">
+            <a:avLst/>
+          </a:prstGeom>
+          <a:solidFill>
+            <a:schemeClr val="bg1">
+              <a:lumMod val="95000"/>
+            </a:schemeClr>
+          </a:solidFill>
+          <a:ln w="28575">
+            <a:solidFill>
+              <a:srgbClr val="E0700D"/>
+            </a:solidFill>
+          </a:ln>
+        </p:spPr>
+        <p:txBody>
+          <a:bodyPr wrap="square" rtlCol="0">
+            <a:spAutoFit/>
+          </a:bodyPr>
+          <a:lstStyle/>
+          <a:p>
+            <a:pPr algn="just"/>
+            <a:endParaRPr lang="en-US" sz="1200" dirty="0">
+              <a:latin typeface="Arial" panose="020B0604020202020204" pitchFamily="34" charset="0"/>
+              <a:cs typeface="Arial" panose="020B0604020202020204" pitchFamily="34" charset="0"/>
+            </a:endParaRPr>
+          </a:p>
+          <a:p>
+            <a:pPr algn="just"/>
+            <a:endParaRPr lang="en-US" sz="1200" dirty="0">
+              <a:latin typeface="Arial" panose="020B0604020202020204" pitchFamily="34" charset="0"/>
+              <a:cs typeface="Arial" panose="020B0604020202020204" pitchFamily="34" charset="0"/>
+            </a:endParaRPr>
+          </a:p>
+          <a:p>
+            <a:pPr algn="just"/>
+            <a:endParaRPr lang="en-US" sz="1200" dirty="0">
+              <a:latin typeface="Arial" panose="020B0604020202020204" pitchFamily="34" charset="0"/>
+              <a:cs typeface="Arial" panose="020B0604020202020204" pitchFamily="34" charset="0"/>
+            </a:endParaRPr>
+          </a:p>
+        </p:txBody>
+      </p:sp>
+      <p:sp>
+        <p:nvSpPr>
+          <p:cNvPr id="4" name="Rectángulo 3">
+            <a:extLst>
+              <a:ext uri="{FF2B5EF4-FFF2-40B4-BE49-F238E27FC236}">
+                <a16:creationId xmlns:a16="http://schemas.microsoft.com/office/drawing/2014/main" id="{2993ADF6-D21D-2668-6DDA-58105166CF68}"/>
+              </a:ext>
+            </a:extLst>
+          </p:cNvPr>
+          <p:cNvSpPr/>
+          <p:nvPr/>
+        </p:nvSpPr>
+        <p:spPr>
+          <a:xfrm>
+            <a:off x="609441" y="1752600"/>
+            <a:ext cx="5332571" cy="2870200"/>
+          </a:xfrm>
+          <a:prstGeom prst="rect">
+            <a:avLst/>
+          </a:prstGeom>
+          <a:noFill/>
+          <a:ln w="28575">
+            <a:solidFill>
+              <a:srgbClr val="E0700D"/>
+            </a:solidFill>
+          </a:ln>
+        </p:spPr>
+        <p:style>
+          <a:lnRef idx="2">
+            <a:schemeClr val="accent1">
+              <a:shade val="15000"/>
+            </a:schemeClr>
+          </a:lnRef>
+          <a:fillRef idx="1">
+            <a:schemeClr val="accent1"/>
+          </a:fillRef>
+          <a:effectRef idx="0">
+            <a:schemeClr val="accent1"/>
+          </a:effectRef>
+          <a:fontRef idx="minor">
+            <a:schemeClr val="lt1"/>
+          </a:fontRef>
+        </p:style>
+        <p:txBody>
+          <a:bodyPr rtlCol="0" anchor="ctr"/>
+          <a:lstStyle/>
+          <a:p>
+            <a:pPr algn="ctr"/>
+            <a:endParaRPr lang="en-US"/>
+          </a:p>
+        </p:txBody>
+      </p:sp>
+      <p:sp>
+        <p:nvSpPr>
+          <p:cNvPr id="5" name="Rectángulo 4">
+            <a:extLst>
+              <a:ext uri="{FF2B5EF4-FFF2-40B4-BE49-F238E27FC236}">
+                <a16:creationId xmlns:a16="http://schemas.microsoft.com/office/drawing/2014/main" id="{BEF898AD-9255-52C1-491D-0B1979BEB031}"/>
+              </a:ext>
+            </a:extLst>
+          </p:cNvPr>
+          <p:cNvSpPr/>
+          <p:nvPr/>
+        </p:nvSpPr>
+        <p:spPr>
+          <a:xfrm>
+            <a:off x="6476841" y="1752600"/>
+            <a:ext cx="5332571" cy="2870200"/>
+          </a:xfrm>
+          <a:prstGeom prst="rect">
+            <a:avLst/>
+          </a:prstGeom>
+          <a:noFill/>
+          <a:ln w="28575">
+            <a:solidFill>
+              <a:srgbClr val="E0700D"/>
+            </a:solidFill>
+          </a:ln>
+        </p:spPr>
+        <p:style>
+          <a:lnRef idx="2">
+            <a:schemeClr val="accent1">
+              <a:shade val="15000"/>
+            </a:schemeClr>
+          </a:lnRef>
+          <a:fillRef idx="1">
+            <a:schemeClr val="accent1"/>
+          </a:fillRef>
+          <a:effectRef idx="0">
+            <a:schemeClr val="accent1"/>
+          </a:effectRef>
+          <a:fontRef idx="minor">
+            <a:schemeClr val="lt1"/>
+          </a:fontRef>
+        </p:style>
+        <p:txBody>
+          <a:bodyPr rtlCol="0" anchor="ctr"/>
+          <a:lstStyle/>
+          <a:p>
+            <a:pPr algn="ctr"/>
+            <a:endParaRPr lang="en-US"/>
+          </a:p>
+        </p:txBody>
+      </p:sp>
+      <p:pic>
+        <p:nvPicPr>
+          <p:cNvPr id="14" name="Imagen 13">
+            <a:extLst>
+              <a:ext uri="{FF2B5EF4-FFF2-40B4-BE49-F238E27FC236}">
+                <a16:creationId xmlns:a16="http://schemas.microsoft.com/office/drawing/2014/main" id="{EC53BC5F-BC37-D980-85A8-6605193EB660}"/>
+              </a:ext>
+            </a:extLst>
+          </p:cNvPr>
+          <p:cNvPicPr>
+            <a:picLocks noChangeAspect="1"/>
+          </p:cNvPicPr>
+          <p:nvPr/>
+        </p:nvPicPr>
+        <p:blipFill>
+          <a:blip r:embed="rId5"/>
+          <a:stretch>
+            <a:fillRect/>
+          </a:stretch>
+        </p:blipFill>
+        <p:spPr>
+          <a:xfrm>
+            <a:off x="1074403" y="1765908"/>
+            <a:ext cx="4798341" cy="2799032"/>
+          </a:xfrm>
+          <a:prstGeom prst="rect">
+            <a:avLst/>
+          </a:prstGeom>
+        </p:spPr>
+      </p:pic>
+      <p:sp>
+        <p:nvSpPr>
+          <p:cNvPr id="12" name="CuadroTexto 11">
+            <a:extLst>
+              <a:ext uri="{FF2B5EF4-FFF2-40B4-BE49-F238E27FC236}">
+                <a16:creationId xmlns:a16="http://schemas.microsoft.com/office/drawing/2014/main" id="{7CFC0A78-BE03-5EC6-463D-56F6288FB880}"/>
+              </a:ext>
+            </a:extLst>
+          </p:cNvPr>
+          <p:cNvSpPr txBox="1"/>
+          <p:nvPr/>
+        </p:nvSpPr>
+        <p:spPr>
+          <a:xfrm>
+            <a:off x="665927" y="4277043"/>
+            <a:ext cx="2269787" cy="338554"/>
+          </a:xfrm>
+          <a:prstGeom prst="rect">
+            <a:avLst/>
+          </a:prstGeom>
+          <a:noFill/>
+        </p:spPr>
+        <p:txBody>
+          <a:bodyPr wrap="square">
+            <a:spAutoFit/>
+          </a:bodyPr>
+          <a:lstStyle/>
+          <a:p>
+            <a:r>
+              <a:rPr lang="en-US" sz="1600" dirty="0"/>
+              <a:t>slab = 150nm</a:t>
+            </a:r>
+            <a:endParaRPr lang="es-ES" sz="1600" dirty="0"/>
+          </a:p>
+        </p:txBody>
+      </p:sp>
+      <p:pic>
+        <p:nvPicPr>
+          <p:cNvPr id="17" name="Imagen 16">
+            <a:extLst>
+              <a:ext uri="{FF2B5EF4-FFF2-40B4-BE49-F238E27FC236}">
+                <a16:creationId xmlns:a16="http://schemas.microsoft.com/office/drawing/2014/main" id="{7FAAAA22-83B2-4C31-47B6-D917F1DCDBB2}"/>
+              </a:ext>
+            </a:extLst>
+          </p:cNvPr>
+          <p:cNvPicPr>
+            <a:picLocks noChangeAspect="1"/>
+          </p:cNvPicPr>
+          <p:nvPr/>
+        </p:nvPicPr>
+        <p:blipFill>
+          <a:blip r:embed="rId6"/>
+          <a:stretch>
+            <a:fillRect/>
+          </a:stretch>
+        </p:blipFill>
+        <p:spPr>
+          <a:xfrm>
+            <a:off x="6882881" y="1846948"/>
+            <a:ext cx="4520490" cy="2636952"/>
+          </a:xfrm>
+          <a:prstGeom prst="rect">
+            <a:avLst/>
+          </a:prstGeom>
+        </p:spPr>
+      </p:pic>
+    </p:spTree>
+    <p:extLst>
+      <p:ext uri="{BB962C8B-B14F-4D97-AF65-F5344CB8AC3E}">
+        <p14:creationId xmlns:p14="http://schemas.microsoft.com/office/powerpoint/2010/main" val="3626364499"/>
+      </p:ext>
+    </p:extLst>
+  </p:cSld>
+  <p:clrMapOvr>
+    <a:masterClrMapping/>
+  </p:clrMapOvr>
+</p:sld>
+</file>
+
+<file path=ppt/slides/slide12.xml><?xml version="1.0" encoding="utf-8"?>
+<p:sld xmlns:a="http://schemas.openxmlformats.org/drawingml/2006/main" xmlns:r="http://schemas.openxmlformats.org/officeDocument/2006/relationships" xmlns:p="http://schemas.openxmlformats.org/presentationml/2006/main">
+  <p:cSld>
+    <p:spTree>
+      <p:nvGrpSpPr>
+        <p:cNvPr id="1" name="">
+          <a:extLst>
+            <a:ext uri="{FF2B5EF4-FFF2-40B4-BE49-F238E27FC236}">
+              <a16:creationId xmlns:a16="http://schemas.microsoft.com/office/drawing/2014/main" id="{ECC43A31-2DA9-8AED-9052-D527F9CE58FF}"/>
+            </a:ext>
+          </a:extLst>
+        </p:cNvPr>
+        <p:cNvGrpSpPr/>
+        <p:nvPr/>
+      </p:nvGrpSpPr>
+      <p:grpSpPr>
+        <a:xfrm>
+          <a:off x="0" y="0"/>
+          <a:ext cx="0" cy="0"/>
+          <a:chOff x="0" y="0"/>
+          <a:chExt cx="0" cy="0"/>
+        </a:xfrm>
+      </p:grpSpPr>
+      <p:sp>
+        <p:nvSpPr>
+          <p:cNvPr id="16" name="object 16">
+            <a:extLst>
+              <a:ext uri="{FF2B5EF4-FFF2-40B4-BE49-F238E27FC236}">
+                <a16:creationId xmlns:a16="http://schemas.microsoft.com/office/drawing/2014/main" id="{7F8C5194-75E5-7874-4FFE-C6C0FC4070AC}"/>
+              </a:ext>
+            </a:extLst>
+          </p:cNvPr>
+          <p:cNvSpPr txBox="1">
+            <a:spLocks noGrp="1"/>
+          </p:cNvSpPr>
+          <p:nvPr>
+            <p:ph type="title"/>
+          </p:nvPr>
+        </p:nvSpPr>
+        <p:spPr>
+          <a:xfrm>
+            <a:off x="685800" y="408883"/>
+            <a:ext cx="10994410" cy="1782539"/>
+          </a:xfrm>
+          <a:prstGeom prst="rect">
+            <a:avLst/>
+          </a:prstGeom>
+        </p:spPr>
+        <p:txBody>
+          <a:bodyPr vert="horz" wrap="square" lIns="0" tIns="12700" rIns="0" bIns="0" rtlCol="0">
+            <a:spAutoFit/>
+          </a:bodyPr>
+          <a:lstStyle/>
+          <a:p>
+            <a:pPr marL="12700">
+              <a:spcBef>
+                <a:spcPts val="100"/>
+              </a:spcBef>
+            </a:pPr>
+            <a:r>
+              <a:rPr lang="en-US" sz="2500" dirty="0"/>
+              <a:t># EXTRA.2 - Width dependence</a:t>
+            </a:r>
+            <a:br>
+              <a:rPr lang="en-US" sz="2500" dirty="0"/>
+            </a:br>
+            <a:r>
+              <a:rPr lang="en-US" dirty="0"/>
+              <a:t>2.</a:t>
+            </a:r>
+            <a:r>
+              <a:rPr lang="en-US" b="0" dirty="0"/>
+              <a:t> Repeat the LO.3. width dependence analysis, now sweeping in a 300nm - 1um range. </a:t>
+            </a:r>
+            <a:br>
+              <a:rPr lang="en-US" b="0" dirty="0"/>
+            </a:br>
+            <a:br>
+              <a:rPr lang="en-US" b="0" dirty="0"/>
+            </a:br>
+            <a:br>
+              <a:rPr lang="en-US" sz="2500" dirty="0"/>
+            </a:br>
+            <a:endParaRPr lang="en-US" sz="2500" b="0" dirty="0">
+              <a:latin typeface="+mj-lt"/>
+              <a:cs typeface="Lucida Sans"/>
+            </a:endParaRPr>
+          </a:p>
+        </p:txBody>
+      </p:sp>
+      <p:pic>
+        <p:nvPicPr>
+          <p:cNvPr id="83" name="Gráfico 82">
+            <a:extLst>
+              <a:ext uri="{FF2B5EF4-FFF2-40B4-BE49-F238E27FC236}">
+                <a16:creationId xmlns:a16="http://schemas.microsoft.com/office/drawing/2014/main" id="{37174BD2-88A1-56BC-6299-366D2C911E3C}"/>
+              </a:ext>
+            </a:extLst>
+          </p:cNvPr>
+          <p:cNvPicPr>
+            <a:picLocks noChangeAspect="1"/>
+          </p:cNvPicPr>
+          <p:nvPr/>
+        </p:nvPicPr>
+        <p:blipFill>
+          <a:blip r:embed="rId3">
+            <a:extLst>
+              <a:ext uri="{96DAC541-7B7A-43D3-8B79-37D633B846F1}">
+                <asvg:svgBlip xmlns:asvg="http://schemas.microsoft.com/office/drawing/2016/SVG/main" r:embed="rId4"/>
+              </a:ext>
+            </a:extLst>
+          </a:blip>
+          <a:stretch>
+            <a:fillRect/>
+          </a:stretch>
+        </p:blipFill>
+        <p:spPr>
+          <a:xfrm>
+            <a:off x="5045006" y="6356057"/>
+            <a:ext cx="6409575" cy="363174"/>
+          </a:xfrm>
+          <a:prstGeom prst="rect">
+            <a:avLst/>
+          </a:prstGeom>
+        </p:spPr>
+      </p:pic>
+      <p:sp>
+        <p:nvSpPr>
+          <p:cNvPr id="84" name="Marcador de número de diapositiva 83">
+            <a:extLst>
+              <a:ext uri="{FF2B5EF4-FFF2-40B4-BE49-F238E27FC236}">
+                <a16:creationId xmlns:a16="http://schemas.microsoft.com/office/drawing/2014/main" id="{ECA7CA9E-67A5-1004-15C0-E24A5FCE8CD4}"/>
+              </a:ext>
+            </a:extLst>
+          </p:cNvPr>
+          <p:cNvSpPr>
+            <a:spLocks noGrp="1"/>
+          </p:cNvSpPr>
+          <p:nvPr>
+            <p:ph type="sldNum" sz="quarter" idx="7"/>
+          </p:nvPr>
+        </p:nvSpPr>
+        <p:spPr/>
+        <p:txBody>
+          <a:bodyPr/>
+          <a:lstStyle/>
+          <a:p>
+            <a:fld id="{B6F15528-21DE-4FAA-801E-634DDDAF4B2B}" type="slidenum">
+              <a:rPr lang="es-ES" smtClean="0"/>
+              <a:t>12</a:t>
+            </a:fld>
+            <a:endParaRPr lang="es-ES"/>
+          </a:p>
+        </p:txBody>
+      </p:sp>
+      <p:sp>
+        <p:nvSpPr>
+          <p:cNvPr id="3" name="Marcador de pie de página 2">
+            <a:extLst>
+              <a:ext uri="{FF2B5EF4-FFF2-40B4-BE49-F238E27FC236}">
+                <a16:creationId xmlns:a16="http://schemas.microsoft.com/office/drawing/2014/main" id="{3BB2435A-FA03-213C-050A-106A34FB237F}"/>
+              </a:ext>
+            </a:extLst>
+          </p:cNvPr>
+          <p:cNvSpPr>
+            <a:spLocks noGrp="1"/>
+          </p:cNvSpPr>
+          <p:nvPr>
+            <p:ph type="ftr" sz="quarter" idx="5"/>
+          </p:nvPr>
+        </p:nvSpPr>
+        <p:spPr/>
+        <p:txBody>
+          <a:bodyPr/>
+          <a:lstStyle/>
+          <a:p>
+            <a:pPr marL="12700">
+              <a:spcBef>
+                <a:spcPts val="15"/>
+              </a:spcBef>
+            </a:pPr>
+            <a:r>
+              <a:rPr lang="es-ES" spc="-5"/>
+              <a:t>LAB 1.0 WAVEGUIDES</a:t>
+            </a:r>
+            <a:endParaRPr lang="es-ES" spc="-5" dirty="0"/>
+          </a:p>
+        </p:txBody>
+      </p:sp>
+      <p:sp>
+        <p:nvSpPr>
+          <p:cNvPr id="2" name="CuadroTexto 1">
+            <a:extLst>
+              <a:ext uri="{FF2B5EF4-FFF2-40B4-BE49-F238E27FC236}">
+                <a16:creationId xmlns:a16="http://schemas.microsoft.com/office/drawing/2014/main" id="{6A2291EA-A955-D9A9-3AA1-672467A8E219}"/>
+              </a:ext>
+            </a:extLst>
+          </p:cNvPr>
+          <p:cNvSpPr txBox="1"/>
+          <p:nvPr/>
+        </p:nvSpPr>
+        <p:spPr>
+          <a:xfrm>
+            <a:off x="609441" y="4860334"/>
+            <a:ext cx="11199971" cy="1015663"/>
+          </a:xfrm>
+          <a:prstGeom prst="rect">
+            <a:avLst/>
+          </a:prstGeom>
+          <a:solidFill>
+            <a:schemeClr val="bg1">
+              <a:lumMod val="95000"/>
+            </a:schemeClr>
+          </a:solidFill>
+          <a:ln w="28575">
+            <a:solidFill>
+              <a:srgbClr val="E0700D"/>
+            </a:solidFill>
+          </a:ln>
+        </p:spPr>
+        <p:txBody>
+          <a:bodyPr wrap="square" rtlCol="0">
+            <a:spAutoFit/>
+          </a:bodyPr>
+          <a:lstStyle/>
+          <a:p>
+            <a:pPr algn="just"/>
+            <a:r>
+              <a:rPr lang="en-US" sz="1200" dirty="0">
+                <a:latin typeface="Arial" panose="020B0604020202020204" pitchFamily="34" charset="0"/>
+                <a:cs typeface="Arial" panose="020B0604020202020204" pitchFamily="34" charset="0"/>
+              </a:rPr>
+              <a:t>a</a:t>
+            </a:r>
+            <a:endParaRPr lang="en-US" sz="1200" u="sng" dirty="0">
+              <a:latin typeface="Arial" panose="020B0604020202020204" pitchFamily="34" charset="0"/>
+              <a:cs typeface="Arial" panose="020B0604020202020204" pitchFamily="34" charset="0"/>
+            </a:endParaRPr>
+          </a:p>
+          <a:p>
+            <a:pPr algn="just"/>
+            <a:endParaRPr lang="en-US" sz="1200" dirty="0">
+              <a:latin typeface="Arial" panose="020B0604020202020204" pitchFamily="34" charset="0"/>
+              <a:cs typeface="Arial" panose="020B0604020202020204" pitchFamily="34" charset="0"/>
+            </a:endParaRPr>
+          </a:p>
+          <a:p>
+            <a:pPr algn="just"/>
+            <a:endParaRPr lang="en-US" sz="1200" dirty="0">
+              <a:latin typeface="Arial" panose="020B0604020202020204" pitchFamily="34" charset="0"/>
+              <a:cs typeface="Arial" panose="020B0604020202020204" pitchFamily="34" charset="0"/>
+            </a:endParaRPr>
+          </a:p>
+          <a:p>
+            <a:pPr algn="just"/>
+            <a:endParaRPr lang="en-US" sz="1200" dirty="0">
+              <a:latin typeface="Arial" panose="020B0604020202020204" pitchFamily="34" charset="0"/>
+              <a:cs typeface="Arial" panose="020B0604020202020204" pitchFamily="34" charset="0"/>
+            </a:endParaRPr>
+          </a:p>
+          <a:p>
+            <a:pPr algn="just"/>
+            <a:endParaRPr lang="en-US" sz="1200" dirty="0">
+              <a:latin typeface="Arial" panose="020B0604020202020204" pitchFamily="34" charset="0"/>
+              <a:cs typeface="Arial" panose="020B0604020202020204" pitchFamily="34" charset="0"/>
+            </a:endParaRPr>
+          </a:p>
+        </p:txBody>
+      </p:sp>
+      <p:sp>
+        <p:nvSpPr>
+          <p:cNvPr id="5" name="Rectángulo 4">
+            <a:extLst>
+              <a:ext uri="{FF2B5EF4-FFF2-40B4-BE49-F238E27FC236}">
+                <a16:creationId xmlns:a16="http://schemas.microsoft.com/office/drawing/2014/main" id="{99C7BC53-FCEA-315B-8AAF-9470C09E243B}"/>
+              </a:ext>
+            </a:extLst>
+          </p:cNvPr>
+          <p:cNvSpPr/>
+          <p:nvPr/>
+        </p:nvSpPr>
+        <p:spPr>
+          <a:xfrm>
+            <a:off x="609441" y="1219200"/>
+            <a:ext cx="11199971" cy="3403600"/>
+          </a:xfrm>
+          <a:prstGeom prst="rect">
+            <a:avLst/>
+          </a:prstGeom>
+          <a:noFill/>
+          <a:ln w="28575">
+            <a:solidFill>
+              <a:srgbClr val="E0700D"/>
+            </a:solidFill>
+          </a:ln>
+        </p:spPr>
+        <p:style>
+          <a:lnRef idx="2">
+            <a:schemeClr val="accent1">
+              <a:shade val="15000"/>
+            </a:schemeClr>
+          </a:lnRef>
+          <a:fillRef idx="1">
+            <a:schemeClr val="accent1"/>
+          </a:fillRef>
+          <a:effectRef idx="0">
+            <a:schemeClr val="accent1"/>
+          </a:effectRef>
+          <a:fontRef idx="minor">
+            <a:schemeClr val="lt1"/>
+          </a:fontRef>
+        </p:style>
+        <p:txBody>
+          <a:bodyPr rtlCol="0" anchor="ctr"/>
+          <a:lstStyle/>
+          <a:p>
+            <a:pPr algn="ctr"/>
+            <a:endParaRPr lang="en-US"/>
+          </a:p>
+        </p:txBody>
+      </p:sp>
+    </p:spTree>
+    <p:extLst>
+      <p:ext uri="{BB962C8B-B14F-4D97-AF65-F5344CB8AC3E}">
+        <p14:creationId xmlns:p14="http://schemas.microsoft.com/office/powerpoint/2010/main" val="894238167"/>
+      </p:ext>
+    </p:extLst>
+  </p:cSld>
+  <p:clrMapOvr>
+    <a:masterClrMapping/>
+  </p:clrMapOvr>
+</p:sld>
+</file>
+
+<file path=ppt/slides/slide13.xml><?xml version="1.0" encoding="utf-8"?>
+<p:sld xmlns:a="http://schemas.openxmlformats.org/drawingml/2006/main" xmlns:r="http://schemas.openxmlformats.org/officeDocument/2006/relationships" xmlns:p="http://schemas.openxmlformats.org/presentationml/2006/main">
+  <p:cSld>
+    <p:spTree>
+      <p:nvGrpSpPr>
+        <p:cNvPr id="1" name="">
+          <a:extLst>
+            <a:ext uri="{FF2B5EF4-FFF2-40B4-BE49-F238E27FC236}">
+              <a16:creationId xmlns:a16="http://schemas.microsoft.com/office/drawing/2014/main" id="{F83BB253-D366-6AC7-6EC6-3467BBA4AC59}"/>
+            </a:ext>
+          </a:extLst>
+        </p:cNvPr>
+        <p:cNvGrpSpPr/>
+        <p:nvPr/>
+      </p:nvGrpSpPr>
+      <p:grpSpPr>
+        <a:xfrm>
+          <a:off x="0" y="0"/>
+          <a:ext cx="0" cy="0"/>
+          <a:chOff x="0" y="0"/>
+          <a:chExt cx="0" cy="0"/>
+        </a:xfrm>
+      </p:grpSpPr>
+      <p:sp>
+        <p:nvSpPr>
+          <p:cNvPr id="16" name="object 16">
+            <a:extLst>
+              <a:ext uri="{FF2B5EF4-FFF2-40B4-BE49-F238E27FC236}">
+                <a16:creationId xmlns:a16="http://schemas.microsoft.com/office/drawing/2014/main" id="{B5EACF51-6C0D-AAF0-97A2-1D61E1878E7C}"/>
+              </a:ext>
+            </a:extLst>
+          </p:cNvPr>
+          <p:cNvSpPr txBox="1">
+            <a:spLocks noGrp="1"/>
+          </p:cNvSpPr>
+          <p:nvPr>
+            <p:ph type="title"/>
+          </p:nvPr>
+        </p:nvSpPr>
+        <p:spPr>
+          <a:xfrm>
+            <a:off x="685800" y="408883"/>
+            <a:ext cx="10994410" cy="1090042"/>
+          </a:xfrm>
+          <a:prstGeom prst="rect">
+            <a:avLst/>
+          </a:prstGeom>
+        </p:spPr>
+        <p:txBody>
+          <a:bodyPr vert="horz" wrap="square" lIns="0" tIns="12700" rIns="0" bIns="0" rtlCol="0">
+            <a:spAutoFit/>
+          </a:bodyPr>
+          <a:lstStyle/>
+          <a:p>
+            <a:pPr marL="12700">
+              <a:spcBef>
+                <a:spcPts val="100"/>
+              </a:spcBef>
+            </a:pPr>
+            <a:r>
+              <a:rPr lang="en-US" sz="2500" dirty="0"/>
+              <a:t># EXTRA.3 - Bend waveguide radius </a:t>
+            </a:r>
+            <a:br>
+              <a:rPr lang="en-US" sz="2500" dirty="0"/>
+            </a:br>
+            <a:r>
+              <a:rPr lang="en-US" dirty="0"/>
+              <a:t>3. </a:t>
+            </a:r>
+            <a:r>
+              <a:rPr lang="en-US" b="0" dirty="0"/>
+              <a:t>Find the safe radius for this technology. Consider sweeping the radius in a 5um to 30um range. </a:t>
+            </a:r>
+            <a:br>
+              <a:rPr lang="en-US" sz="2500" dirty="0"/>
+            </a:br>
+            <a:endParaRPr lang="en-US" sz="2500" b="0" dirty="0">
+              <a:latin typeface="+mj-lt"/>
+              <a:cs typeface="Lucida Sans"/>
+            </a:endParaRPr>
+          </a:p>
+        </p:txBody>
+      </p:sp>
+      <p:pic>
+        <p:nvPicPr>
+          <p:cNvPr id="83" name="Gráfico 82">
+            <a:extLst>
+              <a:ext uri="{FF2B5EF4-FFF2-40B4-BE49-F238E27FC236}">
+                <a16:creationId xmlns:a16="http://schemas.microsoft.com/office/drawing/2014/main" id="{44F58A6F-E893-C84B-50ED-50E27C4DC67B}"/>
+              </a:ext>
+            </a:extLst>
+          </p:cNvPr>
+          <p:cNvPicPr>
+            <a:picLocks noChangeAspect="1"/>
+          </p:cNvPicPr>
+          <p:nvPr/>
+        </p:nvPicPr>
+        <p:blipFill>
+          <a:blip r:embed="rId3">
+            <a:extLst>
+              <a:ext uri="{96DAC541-7B7A-43D3-8B79-37D633B846F1}">
+                <asvg:svgBlip xmlns:asvg="http://schemas.microsoft.com/office/drawing/2016/SVG/main" r:embed="rId4"/>
+              </a:ext>
+            </a:extLst>
+          </a:blip>
+          <a:stretch>
+            <a:fillRect/>
+          </a:stretch>
+        </p:blipFill>
+        <p:spPr>
+          <a:xfrm>
+            <a:off x="5045006" y="6356057"/>
+            <a:ext cx="6409575" cy="363174"/>
+          </a:xfrm>
+          <a:prstGeom prst="rect">
+            <a:avLst/>
+          </a:prstGeom>
+        </p:spPr>
+      </p:pic>
+      <p:sp>
+        <p:nvSpPr>
+          <p:cNvPr id="84" name="Marcador de número de diapositiva 83">
+            <a:extLst>
+              <a:ext uri="{FF2B5EF4-FFF2-40B4-BE49-F238E27FC236}">
+                <a16:creationId xmlns:a16="http://schemas.microsoft.com/office/drawing/2014/main" id="{A6D0AC85-066A-E825-DB4B-6104E5DCF634}"/>
+              </a:ext>
+            </a:extLst>
+          </p:cNvPr>
+          <p:cNvSpPr>
+            <a:spLocks noGrp="1"/>
+          </p:cNvSpPr>
+          <p:nvPr>
+            <p:ph type="sldNum" sz="quarter" idx="7"/>
+          </p:nvPr>
+        </p:nvSpPr>
+        <p:spPr/>
+        <p:txBody>
+          <a:bodyPr/>
+          <a:lstStyle/>
+          <a:p>
+            <a:fld id="{B6F15528-21DE-4FAA-801E-634DDDAF4B2B}" type="slidenum">
+              <a:rPr lang="es-ES" smtClean="0"/>
+              <a:t>13</a:t>
+            </a:fld>
+            <a:endParaRPr lang="es-ES"/>
+          </a:p>
+        </p:txBody>
+      </p:sp>
+      <p:sp>
+        <p:nvSpPr>
+          <p:cNvPr id="3" name="Marcador de pie de página 2">
+            <a:extLst>
+              <a:ext uri="{FF2B5EF4-FFF2-40B4-BE49-F238E27FC236}">
+                <a16:creationId xmlns:a16="http://schemas.microsoft.com/office/drawing/2014/main" id="{0C5A2601-310F-D2C2-25AE-E7A5F5E9E555}"/>
+              </a:ext>
+            </a:extLst>
+          </p:cNvPr>
+          <p:cNvSpPr>
+            <a:spLocks noGrp="1"/>
+          </p:cNvSpPr>
+          <p:nvPr>
+            <p:ph type="ftr" sz="quarter" idx="5"/>
+          </p:nvPr>
+        </p:nvSpPr>
+        <p:spPr/>
+        <p:txBody>
+          <a:bodyPr/>
+          <a:lstStyle/>
+          <a:p>
+            <a:pPr marL="12700">
+              <a:spcBef>
+                <a:spcPts val="15"/>
+              </a:spcBef>
+            </a:pPr>
+            <a:r>
+              <a:rPr lang="es-ES" spc="-5"/>
+              <a:t>LAB 1.0 WAVEGUIDES</a:t>
+            </a:r>
+            <a:endParaRPr lang="es-ES" spc="-5" dirty="0"/>
+          </a:p>
+        </p:txBody>
+      </p:sp>
+      <p:sp>
+        <p:nvSpPr>
+          <p:cNvPr id="2" name="CuadroTexto 1">
+            <a:extLst>
+              <a:ext uri="{FF2B5EF4-FFF2-40B4-BE49-F238E27FC236}">
+                <a16:creationId xmlns:a16="http://schemas.microsoft.com/office/drawing/2014/main" id="{02DCB6B3-3A3C-1858-E0E7-10CB3195D67C}"/>
+              </a:ext>
+            </a:extLst>
+          </p:cNvPr>
+          <p:cNvSpPr txBox="1"/>
+          <p:nvPr/>
+        </p:nvSpPr>
+        <p:spPr>
+          <a:xfrm>
+            <a:off x="609441" y="4860334"/>
+            <a:ext cx="11199971" cy="1200329"/>
+          </a:xfrm>
+          <a:prstGeom prst="rect">
+            <a:avLst/>
+          </a:prstGeom>
+          <a:solidFill>
+            <a:schemeClr val="bg1">
+              <a:lumMod val="95000"/>
+            </a:schemeClr>
+          </a:solidFill>
+          <a:ln w="28575">
+            <a:solidFill>
+              <a:srgbClr val="E0700D"/>
+            </a:solidFill>
+          </a:ln>
+        </p:spPr>
+        <p:txBody>
+          <a:bodyPr wrap="square" rtlCol="0">
+            <a:spAutoFit/>
+          </a:bodyPr>
+          <a:lstStyle/>
+          <a:p>
+            <a:pPr algn="just"/>
+            <a:r>
+              <a:rPr lang="en-US" sz="1200" dirty="0">
+                <a:latin typeface="Arial" panose="020B0604020202020204" pitchFamily="34" charset="0"/>
+                <a:cs typeface="Arial" panose="020B0604020202020204" pitchFamily="34" charset="0"/>
+              </a:rPr>
+              <a:t>a</a:t>
+            </a:r>
+          </a:p>
+          <a:p>
+            <a:pPr algn="just"/>
+            <a:endParaRPr lang="en-US" sz="1200" u="sng" dirty="0">
+              <a:latin typeface="Arial" panose="020B0604020202020204" pitchFamily="34" charset="0"/>
+              <a:cs typeface="Arial" panose="020B0604020202020204" pitchFamily="34" charset="0"/>
+            </a:endParaRPr>
+          </a:p>
+          <a:p>
+            <a:pPr algn="just"/>
+            <a:endParaRPr lang="en-US" sz="1200" dirty="0">
+              <a:latin typeface="Arial" panose="020B0604020202020204" pitchFamily="34" charset="0"/>
+              <a:cs typeface="Arial" panose="020B0604020202020204" pitchFamily="34" charset="0"/>
+            </a:endParaRPr>
+          </a:p>
+          <a:p>
+            <a:pPr algn="just"/>
+            <a:endParaRPr lang="en-US" sz="1200" dirty="0">
+              <a:latin typeface="Arial" panose="020B0604020202020204" pitchFamily="34" charset="0"/>
+              <a:cs typeface="Arial" panose="020B0604020202020204" pitchFamily="34" charset="0"/>
+            </a:endParaRPr>
+          </a:p>
+          <a:p>
+            <a:pPr algn="just"/>
+            <a:endParaRPr lang="en-US" sz="1200" dirty="0">
+              <a:latin typeface="Arial" panose="020B0604020202020204" pitchFamily="34" charset="0"/>
+              <a:cs typeface="Arial" panose="020B0604020202020204" pitchFamily="34" charset="0"/>
+            </a:endParaRPr>
+          </a:p>
+          <a:p>
+            <a:pPr algn="just"/>
+            <a:endParaRPr lang="en-US" sz="1200" dirty="0">
+              <a:latin typeface="Arial" panose="020B0604020202020204" pitchFamily="34" charset="0"/>
+              <a:cs typeface="Arial" panose="020B0604020202020204" pitchFamily="34" charset="0"/>
+            </a:endParaRPr>
+          </a:p>
+        </p:txBody>
+      </p:sp>
+      <p:sp>
+        <p:nvSpPr>
+          <p:cNvPr id="7" name="Rectángulo 6">
+            <a:extLst>
+              <a:ext uri="{FF2B5EF4-FFF2-40B4-BE49-F238E27FC236}">
+                <a16:creationId xmlns:a16="http://schemas.microsoft.com/office/drawing/2014/main" id="{96288F58-55F0-F85E-9BF8-921F152A379D}"/>
+              </a:ext>
+            </a:extLst>
+          </p:cNvPr>
+          <p:cNvSpPr/>
+          <p:nvPr/>
+        </p:nvSpPr>
+        <p:spPr>
+          <a:xfrm>
+            <a:off x="609441" y="1418373"/>
+            <a:ext cx="11199971" cy="3306028"/>
+          </a:xfrm>
+          <a:prstGeom prst="rect">
+            <a:avLst/>
+          </a:prstGeom>
+          <a:noFill/>
+          <a:ln w="28575">
+            <a:solidFill>
+              <a:srgbClr val="E0700D"/>
+            </a:solidFill>
+          </a:ln>
+        </p:spPr>
+        <p:style>
+          <a:lnRef idx="2">
+            <a:schemeClr val="accent1">
+              <a:shade val="15000"/>
+            </a:schemeClr>
+          </a:lnRef>
+          <a:fillRef idx="1">
+            <a:schemeClr val="accent1"/>
+          </a:fillRef>
+          <a:effectRef idx="0">
+            <a:schemeClr val="accent1"/>
+          </a:effectRef>
+          <a:fontRef idx="minor">
+            <a:schemeClr val="lt1"/>
+          </a:fontRef>
+        </p:style>
+        <p:txBody>
+          <a:bodyPr rtlCol="0" anchor="ctr"/>
+          <a:lstStyle/>
+          <a:p>
+            <a:pPr algn="ctr"/>
+            <a:endParaRPr lang="en-US"/>
+          </a:p>
+        </p:txBody>
+      </p:sp>
+    </p:spTree>
+    <p:extLst>
+      <p:ext uri="{BB962C8B-B14F-4D97-AF65-F5344CB8AC3E}">
+        <p14:creationId xmlns:p14="http://schemas.microsoft.com/office/powerpoint/2010/main" val="3390498920"/>
+      </p:ext>
+    </p:extLst>
+  </p:cSld>
+  <p:clrMapOvr>
+    <a:masterClrMapping/>
+  </p:clrMapOvr>
+</p:sld>
+</file>
+
+<file path=ppt/slides/slide14.xml><?xml version="1.0" encoding="utf-8"?>
+<p:sld xmlns:a="http://schemas.openxmlformats.org/drawingml/2006/main" xmlns:r="http://schemas.openxmlformats.org/officeDocument/2006/relationships" xmlns:p="http://schemas.openxmlformats.org/presentationml/2006/main">
+  <p:cSld>
+    <p:spTree>
+      <p:nvGrpSpPr>
+        <p:cNvPr id="1" name="">
+          <a:extLst>
+            <a:ext uri="{FF2B5EF4-FFF2-40B4-BE49-F238E27FC236}">
+              <a16:creationId xmlns:a16="http://schemas.microsoft.com/office/drawing/2014/main" id="{5F793372-9B7F-3F8B-66BA-A27873B241DA}"/>
+            </a:ext>
+          </a:extLst>
+        </p:cNvPr>
+        <p:cNvGrpSpPr/>
+        <p:nvPr/>
+      </p:nvGrpSpPr>
+      <p:grpSpPr>
+        <a:xfrm>
+          <a:off x="0" y="0"/>
+          <a:ext cx="0" cy="0"/>
+          <a:chOff x="0" y="0"/>
+          <a:chExt cx="0" cy="0"/>
+        </a:xfrm>
+      </p:grpSpPr>
+      <p:sp>
+        <p:nvSpPr>
+          <p:cNvPr id="16" name="object 16">
+            <a:extLst>
+              <a:ext uri="{FF2B5EF4-FFF2-40B4-BE49-F238E27FC236}">
+                <a16:creationId xmlns:a16="http://schemas.microsoft.com/office/drawing/2014/main" id="{F5E49F78-BF77-6C19-547B-D0618B73E681}"/>
+              </a:ext>
+            </a:extLst>
+          </p:cNvPr>
+          <p:cNvSpPr txBox="1">
+            <a:spLocks noGrp="1"/>
+          </p:cNvSpPr>
+          <p:nvPr>
+            <p:ph type="title"/>
+          </p:nvPr>
+        </p:nvSpPr>
+        <p:spPr>
+          <a:xfrm>
+            <a:off x="685800" y="408883"/>
+            <a:ext cx="10994410" cy="1090042"/>
+          </a:xfrm>
+          <a:prstGeom prst="rect">
+            <a:avLst/>
+          </a:prstGeom>
+        </p:spPr>
+        <p:txBody>
+          <a:bodyPr vert="horz" wrap="square" lIns="0" tIns="12700" rIns="0" bIns="0" rtlCol="0">
+            <a:spAutoFit/>
+          </a:bodyPr>
+          <a:lstStyle/>
+          <a:p>
+            <a:pPr marL="12700">
+              <a:spcBef>
+                <a:spcPts val="100"/>
+              </a:spcBef>
+            </a:pPr>
+            <a:r>
+              <a:rPr lang="en-US" sz="2500" dirty="0"/>
+              <a:t># EXTRA - Comparative</a:t>
+            </a:r>
+            <a:br>
+              <a:rPr lang="en-US" sz="2500" dirty="0"/>
+            </a:br>
+            <a:r>
+              <a:rPr lang="es-ES" dirty="0"/>
+              <a:t>4. </a:t>
+            </a:r>
+            <a:r>
+              <a:rPr lang="es-ES" b="0" dirty="0"/>
+              <a:t>Compare </a:t>
+            </a:r>
+            <a:r>
+              <a:rPr lang="es-ES" b="0" dirty="0" err="1"/>
+              <a:t>the</a:t>
+            </a:r>
+            <a:r>
+              <a:rPr lang="es-ES" b="0" dirty="0"/>
+              <a:t> </a:t>
+            </a:r>
+            <a:r>
+              <a:rPr lang="es-ES" b="0" dirty="0" err="1"/>
+              <a:t>SiNx</a:t>
+            </a:r>
+            <a:r>
+              <a:rPr lang="es-ES" b="0" dirty="0"/>
+              <a:t> and SOI </a:t>
+            </a:r>
+            <a:r>
+              <a:rPr lang="es-ES" b="0" dirty="0" err="1"/>
+              <a:t>technologies</a:t>
+            </a:r>
+            <a:br>
+              <a:rPr lang="es-ES" b="0" dirty="0"/>
+            </a:br>
+            <a:endParaRPr lang="en-US" sz="2500" b="0" dirty="0">
+              <a:latin typeface="+mj-lt"/>
+              <a:cs typeface="Lucida Sans"/>
+            </a:endParaRPr>
+          </a:p>
+        </p:txBody>
+      </p:sp>
+      <p:pic>
+        <p:nvPicPr>
+          <p:cNvPr id="83" name="Gráfico 82">
+            <a:extLst>
+              <a:ext uri="{FF2B5EF4-FFF2-40B4-BE49-F238E27FC236}">
+                <a16:creationId xmlns:a16="http://schemas.microsoft.com/office/drawing/2014/main" id="{8BF27F03-405A-B058-6A48-6D09BA87FA04}"/>
+              </a:ext>
+            </a:extLst>
+          </p:cNvPr>
+          <p:cNvPicPr>
+            <a:picLocks noChangeAspect="1"/>
+          </p:cNvPicPr>
+          <p:nvPr/>
+        </p:nvPicPr>
+        <p:blipFill>
+          <a:blip r:embed="rId3">
+            <a:extLst>
+              <a:ext uri="{96DAC541-7B7A-43D3-8B79-37D633B846F1}">
+                <asvg:svgBlip xmlns:asvg="http://schemas.microsoft.com/office/drawing/2016/SVG/main" r:embed="rId4"/>
+              </a:ext>
+            </a:extLst>
+          </a:blip>
+          <a:stretch>
+            <a:fillRect/>
+          </a:stretch>
+        </p:blipFill>
+        <p:spPr>
+          <a:xfrm>
+            <a:off x="5045006" y="6356057"/>
+            <a:ext cx="6409575" cy="363174"/>
+          </a:xfrm>
+          <a:prstGeom prst="rect">
+            <a:avLst/>
+          </a:prstGeom>
+        </p:spPr>
+      </p:pic>
+      <p:sp>
+        <p:nvSpPr>
+          <p:cNvPr id="84" name="Marcador de número de diapositiva 83">
+            <a:extLst>
+              <a:ext uri="{FF2B5EF4-FFF2-40B4-BE49-F238E27FC236}">
+                <a16:creationId xmlns:a16="http://schemas.microsoft.com/office/drawing/2014/main" id="{16C77210-3168-5AE1-488E-E190BB6C0E52}"/>
+              </a:ext>
+            </a:extLst>
+          </p:cNvPr>
+          <p:cNvSpPr>
+            <a:spLocks noGrp="1"/>
+          </p:cNvSpPr>
+          <p:nvPr>
+            <p:ph type="sldNum" sz="quarter" idx="7"/>
+          </p:nvPr>
+        </p:nvSpPr>
+        <p:spPr/>
+        <p:txBody>
+          <a:bodyPr/>
+          <a:lstStyle/>
+          <a:p>
+            <a:fld id="{B6F15528-21DE-4FAA-801E-634DDDAF4B2B}" type="slidenum">
+              <a:rPr lang="es-ES" smtClean="0"/>
+              <a:t>14</a:t>
+            </a:fld>
+            <a:endParaRPr lang="es-ES"/>
+          </a:p>
+        </p:txBody>
+      </p:sp>
+      <p:sp>
+        <p:nvSpPr>
+          <p:cNvPr id="3" name="Marcador de pie de página 2">
+            <a:extLst>
+              <a:ext uri="{FF2B5EF4-FFF2-40B4-BE49-F238E27FC236}">
+                <a16:creationId xmlns:a16="http://schemas.microsoft.com/office/drawing/2014/main" id="{9BAA289B-80F5-66DC-E4D9-D509FB485DA7}"/>
+              </a:ext>
+            </a:extLst>
+          </p:cNvPr>
+          <p:cNvSpPr>
+            <a:spLocks noGrp="1"/>
+          </p:cNvSpPr>
+          <p:nvPr>
+            <p:ph type="ftr" sz="quarter" idx="5"/>
+          </p:nvPr>
+        </p:nvSpPr>
+        <p:spPr/>
+        <p:txBody>
+          <a:bodyPr/>
+          <a:lstStyle/>
+          <a:p>
+            <a:pPr marL="12700">
+              <a:spcBef>
+                <a:spcPts val="15"/>
+              </a:spcBef>
+            </a:pPr>
+            <a:r>
+              <a:rPr lang="es-ES" spc="-5"/>
+              <a:t>LAB 1.0 WAVEGUIDES</a:t>
+            </a:r>
+            <a:endParaRPr lang="es-ES" spc="-5" dirty="0"/>
+          </a:p>
+        </p:txBody>
+      </p:sp>
+      <p:sp>
+        <p:nvSpPr>
+          <p:cNvPr id="2" name="CuadroTexto 1">
+            <a:extLst>
+              <a:ext uri="{FF2B5EF4-FFF2-40B4-BE49-F238E27FC236}">
+                <a16:creationId xmlns:a16="http://schemas.microsoft.com/office/drawing/2014/main" id="{81E77402-20CB-B5B9-6221-36355FD8F679}"/>
+              </a:ext>
+            </a:extLst>
+          </p:cNvPr>
+          <p:cNvSpPr txBox="1"/>
+          <p:nvPr/>
+        </p:nvSpPr>
+        <p:spPr>
+          <a:xfrm>
+            <a:off x="609441" y="4860334"/>
+            <a:ext cx="11199971" cy="1015663"/>
+          </a:xfrm>
+          <a:prstGeom prst="rect">
+            <a:avLst/>
+          </a:prstGeom>
+          <a:solidFill>
+            <a:schemeClr val="bg1">
+              <a:lumMod val="95000"/>
+            </a:schemeClr>
+          </a:solidFill>
+          <a:ln w="28575">
+            <a:solidFill>
+              <a:srgbClr val="E0700D"/>
+            </a:solidFill>
+          </a:ln>
+        </p:spPr>
+        <p:txBody>
+          <a:bodyPr wrap="square" rtlCol="0">
+            <a:spAutoFit/>
+          </a:bodyPr>
+          <a:lstStyle/>
+          <a:p>
+            <a:pPr algn="just"/>
+            <a:r>
+              <a:rPr lang="en-US" sz="1200" u="sng" dirty="0">
+                <a:latin typeface="Arial" panose="020B0604020202020204" pitchFamily="34" charset="0"/>
+                <a:cs typeface="Arial" panose="020B0604020202020204" pitchFamily="34" charset="0"/>
+              </a:rPr>
+              <a:t>aa</a:t>
+            </a:r>
+          </a:p>
+          <a:p>
+            <a:pPr algn="just"/>
+            <a:endParaRPr lang="en-US" sz="1200" dirty="0">
+              <a:latin typeface="Arial" panose="020B0604020202020204" pitchFamily="34" charset="0"/>
+              <a:cs typeface="Arial" panose="020B0604020202020204" pitchFamily="34" charset="0"/>
+            </a:endParaRPr>
+          </a:p>
+          <a:p>
+            <a:pPr algn="just"/>
+            <a:endParaRPr lang="en-US" sz="1200" dirty="0">
+              <a:latin typeface="Arial" panose="020B0604020202020204" pitchFamily="34" charset="0"/>
+              <a:cs typeface="Arial" panose="020B0604020202020204" pitchFamily="34" charset="0"/>
+            </a:endParaRPr>
+          </a:p>
+          <a:p>
+            <a:pPr algn="just"/>
+            <a:endParaRPr lang="en-US" sz="1200" dirty="0">
+              <a:latin typeface="Arial" panose="020B0604020202020204" pitchFamily="34" charset="0"/>
+              <a:cs typeface="Arial" panose="020B0604020202020204" pitchFamily="34" charset="0"/>
+            </a:endParaRPr>
+          </a:p>
+          <a:p>
+            <a:pPr algn="just"/>
+            <a:endParaRPr lang="en-US" sz="1200" dirty="0">
+              <a:latin typeface="Arial" panose="020B0604020202020204" pitchFamily="34" charset="0"/>
+              <a:cs typeface="Arial" panose="020B0604020202020204" pitchFamily="34" charset="0"/>
+            </a:endParaRPr>
+          </a:p>
+        </p:txBody>
+      </p:sp>
+      <p:sp>
+        <p:nvSpPr>
+          <p:cNvPr id="7" name="Rectángulo 6">
+            <a:extLst>
+              <a:ext uri="{FF2B5EF4-FFF2-40B4-BE49-F238E27FC236}">
+                <a16:creationId xmlns:a16="http://schemas.microsoft.com/office/drawing/2014/main" id="{2E31592D-03C8-77E9-9305-A5B7EBAC2856}"/>
+              </a:ext>
+            </a:extLst>
+          </p:cNvPr>
+          <p:cNvSpPr/>
+          <p:nvPr/>
+        </p:nvSpPr>
+        <p:spPr>
+          <a:xfrm>
+            <a:off x="609441" y="1418373"/>
+            <a:ext cx="11199971" cy="3306028"/>
+          </a:xfrm>
+          <a:prstGeom prst="rect">
+            <a:avLst/>
+          </a:prstGeom>
+          <a:noFill/>
+          <a:ln w="28575">
+            <a:solidFill>
+              <a:srgbClr val="E0700D"/>
+            </a:solidFill>
+          </a:ln>
+        </p:spPr>
+        <p:style>
+          <a:lnRef idx="2">
+            <a:schemeClr val="accent1">
+              <a:shade val="15000"/>
+            </a:schemeClr>
+          </a:lnRef>
+          <a:fillRef idx="1">
+            <a:schemeClr val="accent1"/>
+          </a:fillRef>
+          <a:effectRef idx="0">
+            <a:schemeClr val="accent1"/>
+          </a:effectRef>
+          <a:fontRef idx="minor">
+            <a:schemeClr val="lt1"/>
+          </a:fontRef>
+        </p:style>
+        <p:txBody>
+          <a:bodyPr rtlCol="0" anchor="ctr"/>
+          <a:lstStyle/>
+          <a:p>
+            <a:pPr algn="ctr"/>
+            <a:endParaRPr lang="en-US"/>
+          </a:p>
+        </p:txBody>
+      </p:sp>
+    </p:spTree>
+    <p:extLst>
+      <p:ext uri="{BB962C8B-B14F-4D97-AF65-F5344CB8AC3E}">
+        <p14:creationId xmlns:p14="http://schemas.microsoft.com/office/powerpoint/2010/main" val="3164561370"/>
+      </p:ext>
+    </p:extLst>
+  </p:cSld>
+  <p:clrMapOvr>
+    <a:masterClrMapping/>
+  </p:clrMapOvr>
+</p:sld>
+</file>
+
+<file path=ppt/slides/slide15.xml><?xml version="1.0" encoding="utf-8"?>
+<p:sld xmlns:a="http://schemas.openxmlformats.org/drawingml/2006/main" xmlns:r="http://schemas.openxmlformats.org/officeDocument/2006/relationships" xmlns:p="http://schemas.openxmlformats.org/presentationml/2006/main">
+  <p:cSld>
+    <p:spTree>
+      <p:nvGrpSpPr>
         <p:cNvPr id="1" name=""/>
         <p:cNvGrpSpPr/>
         <p:nvPr/>
@@ -3763,7 +5684,7 @@
           <a:p>
             <a:fld id="{B6F15528-21DE-4FAA-801E-634DDDAF4B2B}" type="slidenum">
               <a:rPr lang="es-ES" smtClean="0"/>
-              <a:t>11</a:t>
+              <a:t>15</a:t>
             </a:fld>
             <a:endParaRPr lang="es-ES"/>
           </a:p>

</xml_diff>

<commit_message>
en principio todo finalizado hay que comentar
</commit_message>
<xml_diff>
--- a/LabBook_10.pptx
+++ b/LabBook_10.pptx
@@ -3899,7 +3899,7 @@
         <p:spPr>
           <a:xfrm>
             <a:off x="609441" y="1418373"/>
-            <a:ext cx="11199971" cy="3306028"/>
+            <a:ext cx="5484812" cy="3306028"/>
           </a:xfrm>
           <a:prstGeom prst="rect">
             <a:avLst/>
@@ -3936,57 +3936,6 @@
           </a:p>
         </p:txBody>
       </p:sp>
-      <p:sp>
-        <p:nvSpPr>
-          <p:cNvPr id="8" name="CuadroTexto 7">
-            <a:extLst>
-              <a:ext uri="{FF2B5EF4-FFF2-40B4-BE49-F238E27FC236}">
-                <a16:creationId xmlns:a16="http://schemas.microsoft.com/office/drawing/2014/main" id="{331EBD86-BA6C-68C9-2D38-FC8CFBA7ADC4}"/>
-              </a:ext>
-            </a:extLst>
-          </p:cNvPr>
-          <p:cNvSpPr txBox="1"/>
-          <p:nvPr/>
-        </p:nvSpPr>
-        <p:spPr>
-          <a:xfrm>
-            <a:off x="2978141" y="2784355"/>
-            <a:ext cx="6235717" cy="923330"/>
-          </a:xfrm>
-          <a:prstGeom prst="rect">
-            <a:avLst/>
-          </a:prstGeom>
-          <a:noFill/>
-        </p:spPr>
-        <p:txBody>
-          <a:bodyPr wrap="square" rtlCol="0">
-            <a:spAutoFit/>
-          </a:bodyPr>
-          <a:lstStyle/>
-          <a:p>
-            <a:pPr algn="ctr"/>
-            <a:r>
-              <a:rPr lang="en-US" b="1" dirty="0"/>
-              <a:t>deep</a:t>
-            </a:r>
-            <a:r>
-              <a:rPr lang="en-US" dirty="0"/>
-              <a:t> waveguide</a:t>
-            </a:r>
-          </a:p>
-          <a:p>
-            <a:pPr algn="ctr"/>
-            <a:endParaRPr lang="en-US" dirty="0"/>
-          </a:p>
-          <a:p>
-            <a:pPr algn="ctr"/>
-            <a:r>
-              <a:rPr lang="en-US" dirty="0"/>
-              <a:t>Paste Total Loss (dB/90º) vs R &amp; neff_TE0 vs R</a:t>
-            </a:r>
-          </a:p>
-        </p:txBody>
-      </p:sp>
       <p:pic>
         <p:nvPicPr>
           <p:cNvPr id="9" name="Imagen 8">
@@ -4002,15 +3951,20 @@
           <p:nvPr/>
         </p:nvPicPr>
         <p:blipFill>
-          <a:blip r:embed="rId5"/>
-          <a:stretch>
-            <a:fillRect/>
-          </a:stretch>
+          <a:blip r:embed="rId5">
+            <a:extLst>
+              <a:ext uri="{28A0092B-C50C-407E-A947-70E740481C1C}">
+                <a14:useLocalDpi xmlns:a14="http://schemas.microsoft.com/office/drawing/2010/main" val="0"/>
+              </a:ext>
+            </a:extLst>
+          </a:blip>
+          <a:srcRect/>
+          <a:stretch/>
         </p:blipFill>
         <p:spPr>
           <a:xfrm>
-            <a:off x="1524000" y="1739453"/>
-            <a:ext cx="3429000" cy="2708672"/>
+            <a:off x="1370647" y="1538730"/>
+            <a:ext cx="3962400" cy="3130020"/>
           </a:xfrm>
           <a:prstGeom prst="rect">
             <a:avLst/>
@@ -4039,14 +3993,66 @@
         </p:blipFill>
         <p:spPr>
           <a:xfrm>
-            <a:off x="6850725" y="1606918"/>
-            <a:ext cx="3817274" cy="2928937"/>
+            <a:off x="7084512" y="1582601"/>
+            <a:ext cx="3964990" cy="3042277"/>
           </a:xfrm>
           <a:prstGeom prst="rect">
             <a:avLst/>
           </a:prstGeom>
         </p:spPr>
       </p:pic>
+      <p:sp>
+        <p:nvSpPr>
+          <p:cNvPr id="6" name="Rectángulo 5">
+            <a:extLst>
+              <a:ext uri="{FF2B5EF4-FFF2-40B4-BE49-F238E27FC236}">
+                <a16:creationId xmlns:a16="http://schemas.microsoft.com/office/drawing/2014/main" id="{3648DE4D-6003-93D7-5F17-295114C242BF}"/>
+              </a:ext>
+            </a:extLst>
+          </p:cNvPr>
+          <p:cNvSpPr/>
+          <p:nvPr/>
+        </p:nvSpPr>
+        <p:spPr>
+          <a:xfrm>
+            <a:off x="6324601" y="1418373"/>
+            <a:ext cx="5484812" cy="3306028"/>
+          </a:xfrm>
+          <a:prstGeom prst="rect">
+            <a:avLst/>
+          </a:prstGeom>
+          <a:noFill/>
+          <a:ln w="28575">
+            <a:solidFill>
+              <a:srgbClr val="E0700D"/>
+            </a:solidFill>
+          </a:ln>
+        </p:spPr>
+        <p:style>
+          <a:lnRef idx="2">
+            <a:schemeClr val="accent1">
+              <a:shade val="15000"/>
+            </a:schemeClr>
+          </a:lnRef>
+          <a:fillRef idx="1">
+            <a:schemeClr val="accent1"/>
+          </a:fillRef>
+          <a:effectRef idx="0">
+            <a:schemeClr val="accent1"/>
+          </a:effectRef>
+          <a:fontRef idx="minor">
+            <a:schemeClr val="lt1"/>
+          </a:fontRef>
+        </p:style>
+        <p:txBody>
+          <a:bodyPr rtlCol="0" anchor="ctr"/>
+          <a:lstStyle/>
+          <a:p>
+            <a:pPr algn="ctr"/>
+            <a:endParaRPr lang="en-US"/>
+          </a:p>
+        </p:txBody>
+      </p:sp>
     </p:spTree>
     <p:extLst>
       <p:ext uri="{BB962C8B-B14F-4D97-AF65-F5344CB8AC3E}">
@@ -4449,8 +4455,8 @@
         </p:blipFill>
         <p:spPr>
           <a:xfrm>
-            <a:off x="1074403" y="1765908"/>
-            <a:ext cx="4798341" cy="2799032"/>
+            <a:off x="1213329" y="1846948"/>
+            <a:ext cx="4659415" cy="2717992"/>
           </a:xfrm>
           <a:prstGeom prst="rect">
             <a:avLst/>
@@ -4857,6 +4863,36 @@
           </a:p>
         </p:txBody>
       </p:sp>
+      <p:pic>
+        <p:nvPicPr>
+          <p:cNvPr id="6" name="Imagen 5">
+            <a:extLst>
+              <a:ext uri="{FF2B5EF4-FFF2-40B4-BE49-F238E27FC236}">
+                <a16:creationId xmlns:a16="http://schemas.microsoft.com/office/drawing/2014/main" id="{61B0329E-6D40-5235-A888-35A3376E9B5D}"/>
+              </a:ext>
+            </a:extLst>
+          </p:cNvPr>
+          <p:cNvPicPr>
+            <a:picLocks noChangeAspect="1"/>
+          </p:cNvPicPr>
+          <p:nvPr/>
+        </p:nvPicPr>
+        <p:blipFill>
+          <a:blip r:embed="rId5"/>
+          <a:stretch>
+            <a:fillRect/>
+          </a:stretch>
+        </p:blipFill>
+        <p:spPr>
+          <a:xfrm>
+            <a:off x="3372871" y="1271374"/>
+            <a:ext cx="5667428" cy="3299252"/>
+          </a:xfrm>
+          <a:prstGeom prst="rect">
+            <a:avLst/>
+          </a:prstGeom>
+        </p:spPr>
+      </p:pic>
     </p:spTree>
     <p:extLst>
       <p:ext uri="{BB962C8B-B14F-4D97-AF65-F5344CB8AC3E}">
@@ -5136,12 +5172,72 @@
           </a:p>
         </p:txBody>
       </p:sp>
-      <p:sp>
-        <p:nvSpPr>
-          <p:cNvPr id="7" name="Rectángulo 6">
-            <a:extLst>
-              <a:ext uri="{FF2B5EF4-FFF2-40B4-BE49-F238E27FC236}">
-                <a16:creationId xmlns:a16="http://schemas.microsoft.com/office/drawing/2014/main" id="{96288F58-55F0-F85E-9BF8-921F152A379D}"/>
+      <p:pic>
+        <p:nvPicPr>
+          <p:cNvPr id="5" name="Imagen 4">
+            <a:extLst>
+              <a:ext uri="{FF2B5EF4-FFF2-40B4-BE49-F238E27FC236}">
+                <a16:creationId xmlns:a16="http://schemas.microsoft.com/office/drawing/2014/main" id="{C9D037FD-73B4-43A9-F104-658A35532598}"/>
+              </a:ext>
+            </a:extLst>
+          </p:cNvPr>
+          <p:cNvPicPr>
+            <a:picLocks noChangeAspect="1"/>
+          </p:cNvPicPr>
+          <p:nvPr/>
+        </p:nvPicPr>
+        <p:blipFill>
+          <a:blip r:embed="rId5"/>
+          <a:stretch>
+            <a:fillRect/>
+          </a:stretch>
+        </p:blipFill>
+        <p:spPr>
+          <a:xfrm>
+            <a:off x="1389697" y="1571670"/>
+            <a:ext cx="3924300" cy="3057460"/>
+          </a:xfrm>
+          <a:prstGeom prst="rect">
+            <a:avLst/>
+          </a:prstGeom>
+        </p:spPr>
+      </p:pic>
+      <p:pic>
+        <p:nvPicPr>
+          <p:cNvPr id="8" name="Imagen 7">
+            <a:extLst>
+              <a:ext uri="{FF2B5EF4-FFF2-40B4-BE49-F238E27FC236}">
+                <a16:creationId xmlns:a16="http://schemas.microsoft.com/office/drawing/2014/main" id="{12023A00-8315-8679-AF53-7F0834878E82}"/>
+              </a:ext>
+            </a:extLst>
+          </p:cNvPr>
+          <p:cNvPicPr>
+            <a:picLocks noChangeAspect="1"/>
+          </p:cNvPicPr>
+          <p:nvPr/>
+        </p:nvPicPr>
+        <p:blipFill>
+          <a:blip r:embed="rId6"/>
+          <a:stretch>
+            <a:fillRect/>
+          </a:stretch>
+        </p:blipFill>
+        <p:spPr>
+          <a:xfrm>
+            <a:off x="6969447" y="1520808"/>
+            <a:ext cx="4195120" cy="3218852"/>
+          </a:xfrm>
+          <a:prstGeom prst="rect">
+            <a:avLst/>
+          </a:prstGeom>
+        </p:spPr>
+      </p:pic>
+      <p:sp>
+        <p:nvSpPr>
+          <p:cNvPr id="9" name="Rectángulo 8">
+            <a:extLst>
+              <a:ext uri="{FF2B5EF4-FFF2-40B4-BE49-F238E27FC236}">
+                <a16:creationId xmlns:a16="http://schemas.microsoft.com/office/drawing/2014/main" id="{BF1B392D-339F-B2E5-3746-0D3EC9259B0D}"/>
               </a:ext>
             </a:extLst>
           </p:cNvPr>
@@ -5151,7 +5247,59 @@
         <p:spPr>
           <a:xfrm>
             <a:off x="609441" y="1418373"/>
-            <a:ext cx="11199971" cy="3306028"/>
+            <a:ext cx="5484812" cy="3306028"/>
+          </a:xfrm>
+          <a:prstGeom prst="rect">
+            <a:avLst/>
+          </a:prstGeom>
+          <a:noFill/>
+          <a:ln w="28575">
+            <a:solidFill>
+              <a:srgbClr val="E0700D"/>
+            </a:solidFill>
+          </a:ln>
+        </p:spPr>
+        <p:style>
+          <a:lnRef idx="2">
+            <a:schemeClr val="accent1">
+              <a:shade val="15000"/>
+            </a:schemeClr>
+          </a:lnRef>
+          <a:fillRef idx="1">
+            <a:schemeClr val="accent1"/>
+          </a:fillRef>
+          <a:effectRef idx="0">
+            <a:schemeClr val="accent1"/>
+          </a:effectRef>
+          <a:fontRef idx="minor">
+            <a:schemeClr val="lt1"/>
+          </a:fontRef>
+        </p:style>
+        <p:txBody>
+          <a:bodyPr rtlCol="0" anchor="ctr"/>
+          <a:lstStyle/>
+          <a:p>
+            <a:pPr algn="ctr"/>
+            <a:endParaRPr lang="en-US"/>
+          </a:p>
+        </p:txBody>
+      </p:sp>
+      <p:sp>
+        <p:nvSpPr>
+          <p:cNvPr id="10" name="Rectángulo 9">
+            <a:extLst>
+              <a:ext uri="{FF2B5EF4-FFF2-40B4-BE49-F238E27FC236}">
+                <a16:creationId xmlns:a16="http://schemas.microsoft.com/office/drawing/2014/main" id="{23BA1AB5-759C-50A0-873A-DF0F65647685}"/>
+              </a:ext>
+            </a:extLst>
+          </p:cNvPr>
+          <p:cNvSpPr/>
+          <p:nvPr/>
+        </p:nvSpPr>
+        <p:spPr>
+          <a:xfrm>
+            <a:off x="6324601" y="1418373"/>
+            <a:ext cx="5484812" cy="3306028"/>
           </a:xfrm>
           <a:prstGeom prst="rect">
             <a:avLst/>
@@ -10655,57 +10803,6 @@
           </a:p>
         </p:txBody>
       </p:sp>
-      <p:sp>
-        <p:nvSpPr>
-          <p:cNvPr id="8" name="CuadroTexto 7">
-            <a:extLst>
-              <a:ext uri="{FF2B5EF4-FFF2-40B4-BE49-F238E27FC236}">
-                <a16:creationId xmlns:a16="http://schemas.microsoft.com/office/drawing/2014/main" id="{1EF5BFDA-8EC1-8C73-A932-F36C4DB93C73}"/>
-              </a:ext>
-            </a:extLst>
-          </p:cNvPr>
-          <p:cNvSpPr txBox="1"/>
-          <p:nvPr/>
-        </p:nvSpPr>
-        <p:spPr>
-          <a:xfrm>
-            <a:off x="2286000" y="2671278"/>
-            <a:ext cx="7718580" cy="923330"/>
-          </a:xfrm>
-          <a:prstGeom prst="rect">
-            <a:avLst/>
-          </a:prstGeom>
-          <a:noFill/>
-        </p:spPr>
-        <p:txBody>
-          <a:bodyPr wrap="square" rtlCol="0">
-            <a:spAutoFit/>
-          </a:bodyPr>
-          <a:lstStyle/>
-          <a:p>
-            <a:pPr algn="ctr"/>
-            <a:r>
-              <a:rPr lang="en-US" b="1" dirty="0"/>
-              <a:t>deep</a:t>
-            </a:r>
-            <a:r>
-              <a:rPr lang="en-US" dirty="0"/>
-              <a:t> waveguide</a:t>
-            </a:r>
-          </a:p>
-          <a:p>
-            <a:pPr algn="ctr"/>
-            <a:endParaRPr lang="en-US" dirty="0"/>
-          </a:p>
-          <a:p>
-            <a:pPr algn="ctr"/>
-            <a:r>
-              <a:rPr lang="en-US" dirty="0"/>
-              <a:t>Paste plot here</a:t>
-            </a:r>
-          </a:p>
-        </p:txBody>
-      </p:sp>
       <p:pic>
         <p:nvPicPr>
           <p:cNvPr id="9" name="Imagen 8" descr="Gráfico, Gráfico de líneas&#10;&#10;El contenido generado por IA puede ser incorrecto.">
@@ -10728,8 +10825,8 @@
         </p:blipFill>
         <p:spPr>
           <a:xfrm>
-            <a:off x="3335678" y="1472023"/>
-            <a:ext cx="5520643" cy="3213803"/>
+            <a:off x="3380321" y="1516121"/>
+            <a:ext cx="5431357" cy="3161826"/>
           </a:xfrm>
           <a:prstGeom prst="rect">
             <a:avLst/>

</xml_diff>